<commit_message>
Add simulation showcase, result charts, and papers sheet; embed charts in deck
- new_misevolutions/showcase.py: paced terminal simulation that replays the
  recorded runs (evaluator 17->83%, collusion 0->100%, goal drift to 33%),
  with a --live-sample mode that makes real model calls to prove authenticity.
- new_misevolutions/make_charts.py + figures/: 4 presentation charts generated
  from the real result JSONs.
- Deck: slides 28-30 now embed the per-axis charts (replacing the big-number
  callouts) and slide 33 shows the summary chart beside the caveats.
- Misevolution_Related_Papers.xlsx: 15 papers across the 5 extra failure modes
  (name, link, what they solve, limitation), grouped and colour-coded.
</commit_message>
<xml_diff>
--- a/Misevolution_BTP_Presentation.pptx
+++ b/Misevolution_BTP_Presentation.pptx
@@ -17272,202 +17272,33 @@
           </a:p>
         </p:txBody>
       </p:sp>
-      <p:sp>
-        <p:nvSpPr>
-          <p:cNvPr id="7" name="Rectangle 6"/>
-          <p:cNvSpPr/>
-          <p:nvPr/>
-        </p:nvSpPr>
-        <p:spPr>
-          <a:xfrm>
-            <a:off x="6629400" y="1737360"/>
-            <a:ext cx="4983480" cy="1874519"/>
-          </a:xfrm>
-          <a:prstGeom prst="rect">
-            <a:avLst/>
-          </a:prstGeom>
-          <a:solidFill>
-            <a:srgbClr val="F4F5F7"/>
-          </a:solidFill>
-          <a:ln>
-            <a:noFill/>
-          </a:ln>
-          <a:effectLst/>
-        </p:spPr>
-        <p:style>
-          <a:lnRef idx="1">
-            <a:schemeClr val="accent1"/>
-          </a:lnRef>
-          <a:fillRef idx="3">
-            <a:schemeClr val="accent1"/>
-          </a:fillRef>
-          <a:effectRef idx="2">
-            <a:schemeClr val="accent1"/>
-          </a:effectRef>
-          <a:fontRef idx="minor">
-            <a:schemeClr val="lt1"/>
-          </a:fontRef>
-        </p:style>
-        <p:txBody>
-          <a:bodyPr rtlCol="0" anchor="ctr"/>
-          <a:lstStyle/>
-          <a:p>
-            <a:pPr algn="ctr"/>
-          </a:p>
-        </p:txBody>
-      </p:sp>
+      <p:pic>
+        <p:nvPicPr>
+          <p:cNvPr id="7" name="Picture 6" descr="fig_evaluator_drift.png"/>
+          <p:cNvPicPr>
+            <a:picLocks noChangeAspect="1"/>
+          </p:cNvPicPr>
+          <p:nvPr/>
+        </p:nvPicPr>
+        <p:blipFill>
+          <a:blip r:embed="rId2"/>
+          <a:stretch>
+            <a:fillRect/>
+          </a:stretch>
+        </p:blipFill>
+        <p:spPr>
+          <a:xfrm>
+            <a:off x="6355080" y="1783080"/>
+            <a:ext cx="5486400" cy="3328416"/>
+          </a:xfrm>
+          <a:prstGeom prst="rect">
+            <a:avLst/>
+          </a:prstGeom>
+        </p:spPr>
+      </p:pic>
       <p:sp>
         <p:nvSpPr>
           <p:cNvPr id="8" name="Rectangle 7"/>
-          <p:cNvSpPr/>
-          <p:nvPr/>
-        </p:nvSpPr>
-        <p:spPr>
-          <a:xfrm>
-            <a:off x="6629400" y="1737360"/>
-            <a:ext cx="4983480" cy="82296"/>
-          </a:xfrm>
-          <a:prstGeom prst="rect">
-            <a:avLst/>
-          </a:prstGeom>
-          <a:solidFill>
-            <a:srgbClr val="C0392B"/>
-          </a:solidFill>
-          <a:ln>
-            <a:noFill/>
-          </a:ln>
-          <a:effectLst/>
-        </p:spPr>
-        <p:style>
-          <a:lnRef idx="1">
-            <a:schemeClr val="accent1"/>
-          </a:lnRef>
-          <a:fillRef idx="3">
-            <a:schemeClr val="accent1"/>
-          </a:fillRef>
-          <a:effectRef idx="2">
-            <a:schemeClr val="accent1"/>
-          </a:effectRef>
-          <a:fontRef idx="minor">
-            <a:schemeClr val="lt1"/>
-          </a:fontRef>
-        </p:style>
-        <p:txBody>
-          <a:bodyPr rtlCol="0" anchor="ctr"/>
-          <a:lstStyle/>
-          <a:p>
-            <a:pPr algn="ctr"/>
-          </a:p>
-        </p:txBody>
-      </p:sp>
-      <p:sp>
-        <p:nvSpPr>
-          <p:cNvPr id="9" name="TextBox 8"/>
-          <p:cNvSpPr txBox="1"/>
-          <p:nvPr/>
-        </p:nvSpPr>
-        <p:spPr>
-          <a:xfrm>
-            <a:off x="6629400" y="2039112"/>
-            <a:ext cx="4983480" cy="868680"/>
-          </a:xfrm>
-          <a:prstGeom prst="rect">
-            <a:avLst/>
-          </a:prstGeom>
-          <a:noFill/>
-        </p:spPr>
-        <p:txBody>
-          <a:bodyPr wrap="square" anchor="t" lIns="0" rIns="0" tIns="0" bIns="0">
-            <a:spAutoFit/>
-          </a:bodyPr>
-          <a:lstStyle/>
-          <a:p>
-            <a:pPr algn="ctr"/>
-            <a:r>
-              <a:rPr sz="3400" b="1" i="0">
-                <a:solidFill>
-                  <a:srgbClr val="C0392B"/>
-                </a:solidFill>
-                <a:latin typeface="Calibri Light"/>
-              </a:rPr>
-              <a:t>17%   →   83%</a:t>
-            </a:r>
-          </a:p>
-        </p:txBody>
-      </p:sp>
-      <p:sp>
-        <p:nvSpPr>
-          <p:cNvPr id="10" name="TextBox 9"/>
-          <p:cNvSpPr txBox="1"/>
-          <p:nvPr/>
-        </p:nvSpPr>
-        <p:spPr>
-          <a:xfrm>
-            <a:off x="6903720" y="2999232"/>
-            <a:ext cx="4434840" cy="548640"/>
-          </a:xfrm>
-          <a:prstGeom prst="rect">
-            <a:avLst/>
-          </a:prstGeom>
-          <a:noFill/>
-        </p:spPr>
-        <p:txBody>
-          <a:bodyPr wrap="square" anchor="t" lIns="0" rIns="0" tIns="0" bIns="0">
-            <a:spAutoFit/>
-          </a:bodyPr>
-          <a:lstStyle/>
-          <a:p>
-            <a:pPr algn="ctr"/>
-            <a:r>
-              <a:rPr sz="1250" b="0" i="0">
-                <a:solidFill>
-                  <a:srgbClr val="282C35"/>
-                </a:solidFill>
-                <a:latin typeface="Calibri"/>
-              </a:rPr>
-              <a:t>acceptance of clearly-WRONG answers as the judge's biased memory grows (rounds 0 → 8)</a:t>
-            </a:r>
-          </a:p>
-        </p:txBody>
-      </p:sp>
-      <p:sp>
-        <p:nvSpPr>
-          <p:cNvPr id="11" name="TextBox 10"/>
-          <p:cNvSpPr txBox="1"/>
-          <p:nvPr/>
-        </p:nvSpPr>
-        <p:spPr>
-          <a:xfrm>
-            <a:off x="6629400" y="3840480"/>
-            <a:ext cx="4983480" cy="320040"/>
-          </a:xfrm>
-          <a:prstGeom prst="rect">
-            <a:avLst/>
-          </a:prstGeom>
-          <a:noFill/>
-        </p:spPr>
-        <p:txBody>
-          <a:bodyPr wrap="square" anchor="t" lIns="0" rIns="0" tIns="0" bIns="0">
-            <a:spAutoFit/>
-          </a:bodyPr>
-          <a:lstStyle/>
-          <a:p>
-            <a:pPr algn="ctr"/>
-            <a:r>
-              <a:rPr sz="1250" b="1" i="0">
-                <a:solidFill>
-                  <a:srgbClr val="5A616B"/>
-                </a:solidFill>
-                <a:latin typeface="Calibri"/>
-              </a:rPr>
-              <a:t>per round: 17% · 58% · 73% · 89% · 83%</a:t>
-            </a:r>
-          </a:p>
-        </p:txBody>
-      </p:sp>
-      <p:sp>
-        <p:nvSpPr>
-          <p:cNvPr id="12" name="Rectangle 11"/>
           <p:cNvSpPr/>
           <p:nvPr/>
         </p:nvSpPr>
@@ -17511,7 +17342,7 @@
       </p:sp>
       <p:sp>
         <p:nvSpPr>
-          <p:cNvPr id="13" name="TextBox 12"/>
+          <p:cNvPr id="9" name="TextBox 8"/>
           <p:cNvSpPr txBox="1"/>
           <p:nvPr/>
         </p:nvSpPr>
@@ -17546,7 +17377,7 @@
       </p:sp>
       <p:sp>
         <p:nvSpPr>
-          <p:cNvPr id="14" name="TextBox 13"/>
+          <p:cNvPr id="10" name="TextBox 9"/>
           <p:cNvSpPr txBox="1"/>
           <p:nvPr/>
         </p:nvSpPr>
@@ -17878,167 +17709,33 @@
           </a:p>
         </p:txBody>
       </p:sp>
-      <p:sp>
-        <p:nvSpPr>
-          <p:cNvPr id="7" name="Rectangle 6"/>
-          <p:cNvSpPr/>
-          <p:nvPr/>
-        </p:nvSpPr>
-        <p:spPr>
-          <a:xfrm>
-            <a:off x="6629400" y="1737360"/>
-            <a:ext cx="4983480" cy="1874519"/>
-          </a:xfrm>
-          <a:prstGeom prst="rect">
-            <a:avLst/>
-          </a:prstGeom>
-          <a:solidFill>
-            <a:srgbClr val="F4F5F7"/>
-          </a:solidFill>
-          <a:ln>
-            <a:noFill/>
-          </a:ln>
-          <a:effectLst/>
-        </p:spPr>
-        <p:style>
-          <a:lnRef idx="1">
-            <a:schemeClr val="accent1"/>
-          </a:lnRef>
-          <a:fillRef idx="3">
-            <a:schemeClr val="accent1"/>
-          </a:fillRef>
-          <a:effectRef idx="2">
-            <a:schemeClr val="accent1"/>
-          </a:effectRef>
-          <a:fontRef idx="minor">
-            <a:schemeClr val="lt1"/>
-          </a:fontRef>
-        </p:style>
-        <p:txBody>
-          <a:bodyPr rtlCol="0" anchor="ctr"/>
-          <a:lstStyle/>
-          <a:p>
-            <a:pPr algn="ctr"/>
-          </a:p>
-        </p:txBody>
-      </p:sp>
+      <p:pic>
+        <p:nvPicPr>
+          <p:cNvPr id="7" name="Picture 6" descr="fig_collusion.png"/>
+          <p:cNvPicPr>
+            <a:picLocks noChangeAspect="1"/>
+          </p:cNvPicPr>
+          <p:nvPr/>
+        </p:nvPicPr>
+        <p:blipFill>
+          <a:blip r:embed="rId2"/>
+          <a:stretch>
+            <a:fillRect/>
+          </a:stretch>
+        </p:blipFill>
+        <p:spPr>
+          <a:xfrm>
+            <a:off x="6355080" y="1783080"/>
+            <a:ext cx="5486400" cy="3328416"/>
+          </a:xfrm>
+          <a:prstGeom prst="rect">
+            <a:avLst/>
+          </a:prstGeom>
+        </p:spPr>
+      </p:pic>
       <p:sp>
         <p:nvSpPr>
           <p:cNvPr id="8" name="Rectangle 7"/>
-          <p:cNvSpPr/>
-          <p:nvPr/>
-        </p:nvSpPr>
-        <p:spPr>
-          <a:xfrm>
-            <a:off x="6629400" y="1737360"/>
-            <a:ext cx="4983480" cy="82296"/>
-          </a:xfrm>
-          <a:prstGeom prst="rect">
-            <a:avLst/>
-          </a:prstGeom>
-          <a:solidFill>
-            <a:srgbClr val="C0392B"/>
-          </a:solidFill>
-          <a:ln>
-            <a:noFill/>
-          </a:ln>
-          <a:effectLst/>
-        </p:spPr>
-        <p:style>
-          <a:lnRef idx="1">
-            <a:schemeClr val="accent1"/>
-          </a:lnRef>
-          <a:fillRef idx="3">
-            <a:schemeClr val="accent1"/>
-          </a:fillRef>
-          <a:effectRef idx="2">
-            <a:schemeClr val="accent1"/>
-          </a:effectRef>
-          <a:fontRef idx="minor">
-            <a:schemeClr val="lt1"/>
-          </a:fontRef>
-        </p:style>
-        <p:txBody>
-          <a:bodyPr rtlCol="0" anchor="ctr"/>
-          <a:lstStyle/>
-          <a:p>
-            <a:pPr algn="ctr"/>
-          </a:p>
-        </p:txBody>
-      </p:sp>
-      <p:sp>
-        <p:nvSpPr>
-          <p:cNvPr id="9" name="TextBox 8"/>
-          <p:cNvSpPr txBox="1"/>
-          <p:nvPr/>
-        </p:nvSpPr>
-        <p:spPr>
-          <a:xfrm>
-            <a:off x="6629400" y="2039112"/>
-            <a:ext cx="4983480" cy="868680"/>
-          </a:xfrm>
-          <a:prstGeom prst="rect">
-            <a:avLst/>
-          </a:prstGeom>
-          <a:noFill/>
-        </p:spPr>
-        <p:txBody>
-          <a:bodyPr wrap="square" anchor="t" lIns="0" rIns="0" tIns="0" bIns="0">
-            <a:spAutoFit/>
-          </a:bodyPr>
-          <a:lstStyle/>
-          <a:p>
-            <a:pPr algn="ctr"/>
-            <a:r>
-              <a:rPr sz="3400" b="1" i="0">
-                <a:solidFill>
-                  <a:srgbClr val="C0392B"/>
-                </a:solidFill>
-                <a:latin typeface="Calibri Light"/>
-              </a:rPr>
-              <a:t>0%   →   100%</a:t>
-            </a:r>
-          </a:p>
-        </p:txBody>
-      </p:sp>
-      <p:sp>
-        <p:nvSpPr>
-          <p:cNvPr id="10" name="TextBox 9"/>
-          <p:cNvSpPr txBox="1"/>
-          <p:nvPr/>
-        </p:nvSpPr>
-        <p:spPr>
-          <a:xfrm>
-            <a:off x="6903720" y="2999232"/>
-            <a:ext cx="4434840" cy="548640"/>
-          </a:xfrm>
-          <a:prstGeom prst="rect">
-            <a:avLst/>
-          </a:prstGeom>
-          <a:noFill/>
-        </p:spPr>
-        <p:txBody>
-          <a:bodyPr wrap="square" anchor="t" lIns="0" rIns="0" tIns="0" bIns="0">
-            <a:spAutoFit/>
-          </a:bodyPr>
-          <a:lstStyle/>
-          <a:p>
-            <a:pPr algn="ctr"/>
-            <a:r>
-              <a:rPr sz="1250" b="0" i="0">
-                <a:solidFill>
-                  <a:srgbClr val="282C35"/>
-                </a:solidFill>
-                <a:latin typeface="Calibri"/>
-              </a:rPr>
-              <a:t>Reviewer approval of KNOWN-FLAWED work once it shares a shipping reward (rounds 0 → 8)</a:t>
-            </a:r>
-          </a:p>
-        </p:txBody>
-      </p:sp>
-      <p:sp>
-        <p:nvSpPr>
-          <p:cNvPr id="11" name="Rectangle 10"/>
           <p:cNvSpPr/>
           <p:nvPr/>
         </p:nvSpPr>
@@ -18082,7 +17779,7 @@
       </p:sp>
       <p:sp>
         <p:nvSpPr>
-          <p:cNvPr id="12" name="TextBox 11"/>
+          <p:cNvPr id="9" name="TextBox 8"/>
           <p:cNvSpPr txBox="1"/>
           <p:nvPr/>
         </p:nvSpPr>
@@ -18117,7 +17814,7 @@
       </p:sp>
       <p:sp>
         <p:nvSpPr>
-          <p:cNvPr id="13" name="TextBox 12"/>
+          <p:cNvPr id="10" name="TextBox 9"/>
           <p:cNvSpPr txBox="1"/>
           <p:nvPr/>
         </p:nvSpPr>
@@ -18695,730 +18392,33 @@
           </a:p>
         </p:txBody>
       </p:sp>
-      <p:sp>
-        <p:nvSpPr>
-          <p:cNvPr id="7" name="Rectangle 6"/>
-          <p:cNvSpPr/>
-          <p:nvPr/>
-        </p:nvSpPr>
-        <p:spPr>
-          <a:xfrm>
-            <a:off x="6629400" y="1737360"/>
-            <a:ext cx="4983480" cy="1874519"/>
-          </a:xfrm>
-          <a:prstGeom prst="rect">
-            <a:avLst/>
-          </a:prstGeom>
-          <a:solidFill>
-            <a:srgbClr val="F4F5F7"/>
-          </a:solidFill>
-          <a:ln>
-            <a:noFill/>
-          </a:ln>
-          <a:effectLst/>
-        </p:spPr>
-        <p:style>
-          <a:lnRef idx="1">
-            <a:schemeClr val="accent1"/>
-          </a:lnRef>
-          <a:fillRef idx="3">
-            <a:schemeClr val="accent1"/>
-          </a:fillRef>
-          <a:effectRef idx="2">
-            <a:schemeClr val="accent1"/>
-          </a:effectRef>
-          <a:fontRef idx="minor">
-            <a:schemeClr val="lt1"/>
-          </a:fontRef>
-        </p:style>
-        <p:txBody>
-          <a:bodyPr rtlCol="0" anchor="ctr"/>
-          <a:lstStyle/>
-          <a:p>
-            <a:pPr algn="ctr"/>
-          </a:p>
-        </p:txBody>
-      </p:sp>
+      <p:pic>
+        <p:nvPicPr>
+          <p:cNvPr id="7" name="Picture 6" descr="fig_goal_drift.png"/>
+          <p:cNvPicPr>
+            <a:picLocks noChangeAspect="1"/>
+          </p:cNvPicPr>
+          <p:nvPr/>
+        </p:nvPicPr>
+        <p:blipFill>
+          <a:blip r:embed="rId2"/>
+          <a:stretch>
+            <a:fillRect/>
+          </a:stretch>
+        </p:blipFill>
+        <p:spPr>
+          <a:xfrm>
+            <a:off x="6309360" y="2286000"/>
+            <a:ext cx="5532120" cy="2459736"/>
+          </a:xfrm>
+          <a:prstGeom prst="rect">
+            <a:avLst/>
+          </a:prstGeom>
+        </p:spPr>
+      </p:pic>
       <p:sp>
         <p:nvSpPr>
           <p:cNvPr id="8" name="Rectangle 7"/>
-          <p:cNvSpPr/>
-          <p:nvPr/>
-        </p:nvSpPr>
-        <p:spPr>
-          <a:xfrm>
-            <a:off x="6629400" y="1737360"/>
-            <a:ext cx="4983480" cy="82296"/>
-          </a:xfrm>
-          <a:prstGeom prst="rect">
-            <a:avLst/>
-          </a:prstGeom>
-          <a:solidFill>
-            <a:srgbClr val="C0392B"/>
-          </a:solidFill>
-          <a:ln>
-            <a:noFill/>
-          </a:ln>
-          <a:effectLst/>
-        </p:spPr>
-        <p:style>
-          <a:lnRef idx="1">
-            <a:schemeClr val="accent1"/>
-          </a:lnRef>
-          <a:fillRef idx="3">
-            <a:schemeClr val="accent1"/>
-          </a:fillRef>
-          <a:effectRef idx="2">
-            <a:schemeClr val="accent1"/>
-          </a:effectRef>
-          <a:fontRef idx="minor">
-            <a:schemeClr val="lt1"/>
-          </a:fontRef>
-        </p:style>
-        <p:txBody>
-          <a:bodyPr rtlCol="0" anchor="ctr"/>
-          <a:lstStyle/>
-          <a:p>
-            <a:pPr algn="ctr"/>
-          </a:p>
-        </p:txBody>
-      </p:sp>
-      <p:sp>
-        <p:nvSpPr>
-          <p:cNvPr id="9" name="TextBox 8"/>
-          <p:cNvSpPr txBox="1"/>
-          <p:nvPr/>
-        </p:nvSpPr>
-        <p:spPr>
-          <a:xfrm>
-            <a:off x="6629400" y="2039112"/>
-            <a:ext cx="4983480" cy="868680"/>
-          </a:xfrm>
-          <a:prstGeom prst="rect">
-            <a:avLst/>
-          </a:prstGeom>
-          <a:noFill/>
-        </p:spPr>
-        <p:txBody>
-          <a:bodyPr wrap="square" anchor="t" lIns="0" rIns="0" tIns="0" bIns="0">
-            <a:spAutoFit/>
-          </a:bodyPr>
-          <a:lstStyle/>
-          <a:p>
-            <a:pPr algn="ctr"/>
-            <a:r>
-              <a:rPr sz="3400" b="1" i="0">
-                <a:solidFill>
-                  <a:srgbClr val="C0392B"/>
-                </a:solidFill>
-                <a:latin typeface="Calibri Light"/>
-              </a:rPr>
-              <a:t>turn 2   →   33%</a:t>
-            </a:r>
-          </a:p>
-        </p:txBody>
-      </p:sp>
-      <p:sp>
-        <p:nvSpPr>
-          <p:cNvPr id="10" name="TextBox 9"/>
-          <p:cNvSpPr txBox="1"/>
-          <p:nvPr/>
-        </p:nvSpPr>
-        <p:spPr>
-          <a:xfrm>
-            <a:off x="6903720" y="2999232"/>
-            <a:ext cx="4434840" cy="548640"/>
-          </a:xfrm>
-          <a:prstGeom prst="rect">
-            <a:avLst/>
-          </a:prstGeom>
-          <a:noFill/>
-        </p:spPr>
-        <p:txBody>
-          <a:bodyPr wrap="square" anchor="t" lIns="0" rIns="0" tIns="0" bIns="0">
-            <a:spAutoFit/>
-          </a:bodyPr>
-          <a:lstStyle/>
-          <a:p>
-            <a:pPr algn="ctr"/>
-            <a:r>
-              <a:rPr sz="1250" b="0" i="0">
-                <a:solidFill>
-                  <a:srgbClr val="282C35"/>
-                </a:solidFill>
-                <a:latin typeface="Calibri"/>
-              </a:rPr>
-              <a:t>first defection at turn 2 of 12; the goal held on only 33% of turns under pressure</a:t>
-            </a:r>
-          </a:p>
-        </p:txBody>
-      </p:sp>
-      <p:sp>
-        <p:nvSpPr>
-          <p:cNvPr id="11" name="Rectangle 10"/>
-          <p:cNvSpPr/>
-          <p:nvPr/>
-        </p:nvSpPr>
-        <p:spPr>
-          <a:xfrm>
-            <a:off x="6720840" y="3840480"/>
-            <a:ext cx="338328" cy="338328"/>
-          </a:xfrm>
-          <a:prstGeom prst="rect">
-            <a:avLst/>
-          </a:prstGeom>
-          <a:solidFill>
-            <a:srgbClr val="2E7D5B"/>
-          </a:solidFill>
-          <a:ln>
-            <a:noFill/>
-          </a:ln>
-          <a:effectLst/>
-        </p:spPr>
-        <p:style>
-          <a:lnRef idx="1">
-            <a:schemeClr val="accent1"/>
-          </a:lnRef>
-          <a:fillRef idx="3">
-            <a:schemeClr val="accent1"/>
-          </a:fillRef>
-          <a:effectRef idx="2">
-            <a:schemeClr val="accent1"/>
-          </a:effectRef>
-          <a:fontRef idx="minor">
-            <a:schemeClr val="lt1"/>
-          </a:fontRef>
-        </p:style>
-        <p:txBody>
-          <a:bodyPr rtlCol="0" anchor="ctr"/>
-          <a:lstStyle/>
-          <a:p>
-            <a:pPr algn="ctr"/>
-          </a:p>
-        </p:txBody>
-      </p:sp>
-      <p:sp>
-        <p:nvSpPr>
-          <p:cNvPr id="12" name="Rectangle 11"/>
-          <p:cNvSpPr/>
-          <p:nvPr/>
-        </p:nvSpPr>
-        <p:spPr>
-          <a:xfrm>
-            <a:off x="7114032" y="3840480"/>
-            <a:ext cx="338328" cy="338328"/>
-          </a:xfrm>
-          <a:prstGeom prst="rect">
-            <a:avLst/>
-          </a:prstGeom>
-          <a:solidFill>
-            <a:srgbClr val="C0392B"/>
-          </a:solidFill>
-          <a:ln>
-            <a:noFill/>
-          </a:ln>
-          <a:effectLst/>
-        </p:spPr>
-        <p:style>
-          <a:lnRef idx="1">
-            <a:schemeClr val="accent1"/>
-          </a:lnRef>
-          <a:fillRef idx="3">
-            <a:schemeClr val="accent1"/>
-          </a:fillRef>
-          <a:effectRef idx="2">
-            <a:schemeClr val="accent1"/>
-          </a:effectRef>
-          <a:fontRef idx="minor">
-            <a:schemeClr val="lt1"/>
-          </a:fontRef>
-        </p:style>
-        <p:txBody>
-          <a:bodyPr rtlCol="0" anchor="ctr"/>
-          <a:lstStyle/>
-          <a:p>
-            <a:pPr algn="ctr"/>
-          </a:p>
-        </p:txBody>
-      </p:sp>
-      <p:sp>
-        <p:nvSpPr>
-          <p:cNvPr id="13" name="Rectangle 12"/>
-          <p:cNvSpPr/>
-          <p:nvPr/>
-        </p:nvSpPr>
-        <p:spPr>
-          <a:xfrm>
-            <a:off x="7507224" y="3840480"/>
-            <a:ext cx="338328" cy="338328"/>
-          </a:xfrm>
-          <a:prstGeom prst="rect">
-            <a:avLst/>
-          </a:prstGeom>
-          <a:solidFill>
-            <a:srgbClr val="C0392B"/>
-          </a:solidFill>
-          <a:ln>
-            <a:noFill/>
-          </a:ln>
-          <a:effectLst/>
-        </p:spPr>
-        <p:style>
-          <a:lnRef idx="1">
-            <a:schemeClr val="accent1"/>
-          </a:lnRef>
-          <a:fillRef idx="3">
-            <a:schemeClr val="accent1"/>
-          </a:fillRef>
-          <a:effectRef idx="2">
-            <a:schemeClr val="accent1"/>
-          </a:effectRef>
-          <a:fontRef idx="minor">
-            <a:schemeClr val="lt1"/>
-          </a:fontRef>
-        </p:style>
-        <p:txBody>
-          <a:bodyPr rtlCol="0" anchor="ctr"/>
-          <a:lstStyle/>
-          <a:p>
-            <a:pPr algn="ctr"/>
-          </a:p>
-        </p:txBody>
-      </p:sp>
-      <p:sp>
-        <p:nvSpPr>
-          <p:cNvPr id="14" name="Rectangle 13"/>
-          <p:cNvSpPr/>
-          <p:nvPr/>
-        </p:nvSpPr>
-        <p:spPr>
-          <a:xfrm>
-            <a:off x="7900416" y="3840480"/>
-            <a:ext cx="338328" cy="338328"/>
-          </a:xfrm>
-          <a:prstGeom prst="rect">
-            <a:avLst/>
-          </a:prstGeom>
-          <a:solidFill>
-            <a:srgbClr val="2E7D5B"/>
-          </a:solidFill>
-          <a:ln>
-            <a:noFill/>
-          </a:ln>
-          <a:effectLst/>
-        </p:spPr>
-        <p:style>
-          <a:lnRef idx="1">
-            <a:schemeClr val="accent1"/>
-          </a:lnRef>
-          <a:fillRef idx="3">
-            <a:schemeClr val="accent1"/>
-          </a:fillRef>
-          <a:effectRef idx="2">
-            <a:schemeClr val="accent1"/>
-          </a:effectRef>
-          <a:fontRef idx="minor">
-            <a:schemeClr val="lt1"/>
-          </a:fontRef>
-        </p:style>
-        <p:txBody>
-          <a:bodyPr rtlCol="0" anchor="ctr"/>
-          <a:lstStyle/>
-          <a:p>
-            <a:pPr algn="ctr"/>
-          </a:p>
-        </p:txBody>
-      </p:sp>
-      <p:sp>
-        <p:nvSpPr>
-          <p:cNvPr id="15" name="Rectangle 14"/>
-          <p:cNvSpPr/>
-          <p:nvPr/>
-        </p:nvSpPr>
-        <p:spPr>
-          <a:xfrm>
-            <a:off x="8293608" y="3840480"/>
-            <a:ext cx="338328" cy="338328"/>
-          </a:xfrm>
-          <a:prstGeom prst="rect">
-            <a:avLst/>
-          </a:prstGeom>
-          <a:solidFill>
-            <a:srgbClr val="C0392B"/>
-          </a:solidFill>
-          <a:ln>
-            <a:noFill/>
-          </a:ln>
-          <a:effectLst/>
-        </p:spPr>
-        <p:style>
-          <a:lnRef idx="1">
-            <a:schemeClr val="accent1"/>
-          </a:lnRef>
-          <a:fillRef idx="3">
-            <a:schemeClr val="accent1"/>
-          </a:fillRef>
-          <a:effectRef idx="2">
-            <a:schemeClr val="accent1"/>
-          </a:effectRef>
-          <a:fontRef idx="minor">
-            <a:schemeClr val="lt1"/>
-          </a:fontRef>
-        </p:style>
-        <p:txBody>
-          <a:bodyPr rtlCol="0" anchor="ctr"/>
-          <a:lstStyle/>
-          <a:p>
-            <a:pPr algn="ctr"/>
-          </a:p>
-        </p:txBody>
-      </p:sp>
-      <p:sp>
-        <p:nvSpPr>
-          <p:cNvPr id="16" name="Rectangle 15"/>
-          <p:cNvSpPr/>
-          <p:nvPr/>
-        </p:nvSpPr>
-        <p:spPr>
-          <a:xfrm>
-            <a:off x="8686800" y="3840480"/>
-            <a:ext cx="338328" cy="338328"/>
-          </a:xfrm>
-          <a:prstGeom prst="rect">
-            <a:avLst/>
-          </a:prstGeom>
-          <a:solidFill>
-            <a:srgbClr val="C0392B"/>
-          </a:solidFill>
-          <a:ln>
-            <a:noFill/>
-          </a:ln>
-          <a:effectLst/>
-        </p:spPr>
-        <p:style>
-          <a:lnRef idx="1">
-            <a:schemeClr val="accent1"/>
-          </a:lnRef>
-          <a:fillRef idx="3">
-            <a:schemeClr val="accent1"/>
-          </a:fillRef>
-          <a:effectRef idx="2">
-            <a:schemeClr val="accent1"/>
-          </a:effectRef>
-          <a:fontRef idx="minor">
-            <a:schemeClr val="lt1"/>
-          </a:fontRef>
-        </p:style>
-        <p:txBody>
-          <a:bodyPr rtlCol="0" anchor="ctr"/>
-          <a:lstStyle/>
-          <a:p>
-            <a:pPr algn="ctr"/>
-          </a:p>
-        </p:txBody>
-      </p:sp>
-      <p:sp>
-        <p:nvSpPr>
-          <p:cNvPr id="17" name="Rectangle 16"/>
-          <p:cNvSpPr/>
-          <p:nvPr/>
-        </p:nvSpPr>
-        <p:spPr>
-          <a:xfrm>
-            <a:off x="9079992" y="3840480"/>
-            <a:ext cx="338328" cy="338328"/>
-          </a:xfrm>
-          <a:prstGeom prst="rect">
-            <a:avLst/>
-          </a:prstGeom>
-          <a:solidFill>
-            <a:srgbClr val="C0392B"/>
-          </a:solidFill>
-          <a:ln>
-            <a:noFill/>
-          </a:ln>
-          <a:effectLst/>
-        </p:spPr>
-        <p:style>
-          <a:lnRef idx="1">
-            <a:schemeClr val="accent1"/>
-          </a:lnRef>
-          <a:fillRef idx="3">
-            <a:schemeClr val="accent1"/>
-          </a:fillRef>
-          <a:effectRef idx="2">
-            <a:schemeClr val="accent1"/>
-          </a:effectRef>
-          <a:fontRef idx="minor">
-            <a:schemeClr val="lt1"/>
-          </a:fontRef>
-        </p:style>
-        <p:txBody>
-          <a:bodyPr rtlCol="0" anchor="ctr"/>
-          <a:lstStyle/>
-          <a:p>
-            <a:pPr algn="ctr"/>
-          </a:p>
-        </p:txBody>
-      </p:sp>
-      <p:sp>
-        <p:nvSpPr>
-          <p:cNvPr id="18" name="Rectangle 17"/>
-          <p:cNvSpPr/>
-          <p:nvPr/>
-        </p:nvSpPr>
-        <p:spPr>
-          <a:xfrm>
-            <a:off x="9473184" y="3840480"/>
-            <a:ext cx="338328" cy="338328"/>
-          </a:xfrm>
-          <a:prstGeom prst="rect">
-            <a:avLst/>
-          </a:prstGeom>
-          <a:solidFill>
-            <a:srgbClr val="C0392B"/>
-          </a:solidFill>
-          <a:ln>
-            <a:noFill/>
-          </a:ln>
-          <a:effectLst/>
-        </p:spPr>
-        <p:style>
-          <a:lnRef idx="1">
-            <a:schemeClr val="accent1"/>
-          </a:lnRef>
-          <a:fillRef idx="3">
-            <a:schemeClr val="accent1"/>
-          </a:fillRef>
-          <a:effectRef idx="2">
-            <a:schemeClr val="accent1"/>
-          </a:effectRef>
-          <a:fontRef idx="minor">
-            <a:schemeClr val="lt1"/>
-          </a:fontRef>
-        </p:style>
-        <p:txBody>
-          <a:bodyPr rtlCol="0" anchor="ctr"/>
-          <a:lstStyle/>
-          <a:p>
-            <a:pPr algn="ctr"/>
-          </a:p>
-        </p:txBody>
-      </p:sp>
-      <p:sp>
-        <p:nvSpPr>
-          <p:cNvPr id="19" name="Rectangle 18"/>
-          <p:cNvSpPr/>
-          <p:nvPr/>
-        </p:nvSpPr>
-        <p:spPr>
-          <a:xfrm>
-            <a:off x="9866376" y="3840480"/>
-            <a:ext cx="338328" cy="338328"/>
-          </a:xfrm>
-          <a:prstGeom prst="rect">
-            <a:avLst/>
-          </a:prstGeom>
-          <a:solidFill>
-            <a:srgbClr val="2E7D5B"/>
-          </a:solidFill>
-          <a:ln>
-            <a:noFill/>
-          </a:ln>
-          <a:effectLst/>
-        </p:spPr>
-        <p:style>
-          <a:lnRef idx="1">
-            <a:schemeClr val="accent1"/>
-          </a:lnRef>
-          <a:fillRef idx="3">
-            <a:schemeClr val="accent1"/>
-          </a:fillRef>
-          <a:effectRef idx="2">
-            <a:schemeClr val="accent1"/>
-          </a:effectRef>
-          <a:fontRef idx="minor">
-            <a:schemeClr val="lt1"/>
-          </a:fontRef>
-        </p:style>
-        <p:txBody>
-          <a:bodyPr rtlCol="0" anchor="ctr"/>
-          <a:lstStyle/>
-          <a:p>
-            <a:pPr algn="ctr"/>
-          </a:p>
-        </p:txBody>
-      </p:sp>
-      <p:sp>
-        <p:nvSpPr>
-          <p:cNvPr id="20" name="Rectangle 19"/>
-          <p:cNvSpPr/>
-          <p:nvPr/>
-        </p:nvSpPr>
-        <p:spPr>
-          <a:xfrm>
-            <a:off x="10259568" y="3840480"/>
-            <a:ext cx="338328" cy="338328"/>
-          </a:xfrm>
-          <a:prstGeom prst="rect">
-            <a:avLst/>
-          </a:prstGeom>
-          <a:solidFill>
-            <a:srgbClr val="2E7D5B"/>
-          </a:solidFill>
-          <a:ln>
-            <a:noFill/>
-          </a:ln>
-          <a:effectLst/>
-        </p:spPr>
-        <p:style>
-          <a:lnRef idx="1">
-            <a:schemeClr val="accent1"/>
-          </a:lnRef>
-          <a:fillRef idx="3">
-            <a:schemeClr val="accent1"/>
-          </a:fillRef>
-          <a:effectRef idx="2">
-            <a:schemeClr val="accent1"/>
-          </a:effectRef>
-          <a:fontRef idx="minor">
-            <a:schemeClr val="lt1"/>
-          </a:fontRef>
-        </p:style>
-        <p:txBody>
-          <a:bodyPr rtlCol="0" anchor="ctr"/>
-          <a:lstStyle/>
-          <a:p>
-            <a:pPr algn="ctr"/>
-          </a:p>
-        </p:txBody>
-      </p:sp>
-      <p:sp>
-        <p:nvSpPr>
-          <p:cNvPr id="21" name="Rectangle 20"/>
-          <p:cNvSpPr/>
-          <p:nvPr/>
-        </p:nvSpPr>
-        <p:spPr>
-          <a:xfrm>
-            <a:off x="10652760" y="3840480"/>
-            <a:ext cx="338328" cy="338328"/>
-          </a:xfrm>
-          <a:prstGeom prst="rect">
-            <a:avLst/>
-          </a:prstGeom>
-          <a:solidFill>
-            <a:srgbClr val="C0392B"/>
-          </a:solidFill>
-          <a:ln>
-            <a:noFill/>
-          </a:ln>
-          <a:effectLst/>
-        </p:spPr>
-        <p:style>
-          <a:lnRef idx="1">
-            <a:schemeClr val="accent1"/>
-          </a:lnRef>
-          <a:fillRef idx="3">
-            <a:schemeClr val="accent1"/>
-          </a:fillRef>
-          <a:effectRef idx="2">
-            <a:schemeClr val="accent1"/>
-          </a:effectRef>
-          <a:fontRef idx="minor">
-            <a:schemeClr val="lt1"/>
-          </a:fontRef>
-        </p:style>
-        <p:txBody>
-          <a:bodyPr rtlCol="0" anchor="ctr"/>
-          <a:lstStyle/>
-          <a:p>
-            <a:pPr algn="ctr"/>
-          </a:p>
-        </p:txBody>
-      </p:sp>
-      <p:sp>
-        <p:nvSpPr>
-          <p:cNvPr id="22" name="Rectangle 21"/>
-          <p:cNvSpPr/>
-          <p:nvPr/>
-        </p:nvSpPr>
-        <p:spPr>
-          <a:xfrm>
-            <a:off x="11045952" y="3840480"/>
-            <a:ext cx="338328" cy="338328"/>
-          </a:xfrm>
-          <a:prstGeom prst="rect">
-            <a:avLst/>
-          </a:prstGeom>
-          <a:solidFill>
-            <a:srgbClr val="C0392B"/>
-          </a:solidFill>
-          <a:ln>
-            <a:noFill/>
-          </a:ln>
-          <a:effectLst/>
-        </p:spPr>
-        <p:style>
-          <a:lnRef idx="1">
-            <a:schemeClr val="accent1"/>
-          </a:lnRef>
-          <a:fillRef idx="3">
-            <a:schemeClr val="accent1"/>
-          </a:fillRef>
-          <a:effectRef idx="2">
-            <a:schemeClr val="accent1"/>
-          </a:effectRef>
-          <a:fontRef idx="minor">
-            <a:schemeClr val="lt1"/>
-          </a:fontRef>
-        </p:style>
-        <p:txBody>
-          <a:bodyPr rtlCol="0" anchor="ctr"/>
-          <a:lstStyle/>
-          <a:p>
-            <a:pPr algn="ctr"/>
-          </a:p>
-        </p:txBody>
-      </p:sp>
-      <p:sp>
-        <p:nvSpPr>
-          <p:cNvPr id="23" name="TextBox 22"/>
-          <p:cNvSpPr txBox="1"/>
-          <p:nvPr/>
-        </p:nvSpPr>
-        <p:spPr>
-          <a:xfrm>
-            <a:off x="6629400" y="4279392"/>
-            <a:ext cx="4983480" cy="274320"/>
-          </a:xfrm>
-          <a:prstGeom prst="rect">
-            <a:avLst/>
-          </a:prstGeom>
-          <a:noFill/>
-        </p:spPr>
-        <p:txBody>
-          <a:bodyPr wrap="square" anchor="t" lIns="0" rIns="0" tIns="0" bIns="0">
-            <a:spAutoFit/>
-          </a:bodyPr>
-          <a:lstStyle/>
-          <a:p>
-            <a:pPr algn="ctr"/>
-            <a:r>
-              <a:rPr sz="1100" b="0" i="0">
-                <a:solidFill>
-                  <a:srgbClr val="5A616B"/>
-                </a:solidFill>
-                <a:latin typeface="Calibri"/>
-              </a:rPr>
-              <a:t>held ■   caved ■   (turns 1–12)</a:t>
-            </a:r>
-          </a:p>
-        </p:txBody>
-      </p:sp>
-      <p:sp>
-        <p:nvSpPr>
-          <p:cNvPr id="24" name="Rectangle 23"/>
           <p:cNvSpPr/>
           <p:nvPr/>
         </p:nvSpPr>
@@ -19462,7 +18462,7 @@
       </p:sp>
       <p:sp>
         <p:nvSpPr>
-          <p:cNvPr id="25" name="TextBox 24"/>
+          <p:cNvPr id="9" name="TextBox 8"/>
           <p:cNvSpPr txBox="1"/>
           <p:nvPr/>
         </p:nvSpPr>
@@ -19497,7 +18497,7 @@
       </p:sp>
       <p:sp>
         <p:nvSpPr>
-          <p:cNvPr id="26" name="TextBox 25"/>
+          <p:cNvPr id="10" name="TextBox 9"/>
           <p:cNvSpPr txBox="1"/>
           <p:nvPr/>
         </p:nvSpPr>
@@ -21543,410 +20543,30 @@
           </a:p>
         </p:txBody>
       </p:sp>
-      <p:graphicFrame>
-        <p:nvGraphicFramePr>
-          <p:cNvPr id="6" name="Table 5"/>
-          <p:cNvGraphicFramePr>
-            <a:graphicFrameLocks noGrp="1"/>
-          </p:cNvGraphicFramePr>
-          <p:nvPr/>
-        </p:nvGraphicFramePr>
-        <p:xfrm>
-          <a:off x="548640" y="1828800"/>
-          <a:ext cx="11064240" cy="2633472"/>
-        </p:xfrm>
-        <a:graphic>
-          <a:graphicData uri="http://schemas.openxmlformats.org/drawingml/2006/table">
-            <a:tbl>
-              <a:tblPr firstRow="1" bandRow="1">
-                <a:tableStyleId>{5C22544A-7EE6-4342-B048-85BDC9FD1C3A}</a:tableStyleId>
-              </a:tblPr>
-              <a:tblGrid>
-                <a:gridCol w="2468880"/>
-                <a:gridCol w="4114800"/>
-                <a:gridCol w="2240280"/>
-                <a:gridCol w="2240280"/>
-              </a:tblGrid>
-              <a:tr h="658368">
-                <a:tc>
-                  <a:txBody>
-                    <a:bodyPr/>
-                    <a:lstStyle/>
-                    <a:p>
-                      <a:pPr algn="l"/>
-                      <a:r>
-                        <a:rPr sz="1200" b="1">
-                          <a:solidFill>
-                            <a:srgbClr val="FFFFFF"/>
-                          </a:solidFill>
-                          <a:latin typeface="Calibri"/>
-                        </a:rPr>
-                        <a:t>New axis</a:t>
-                      </a:r>
-                    </a:p>
-                  </a:txBody>
-                  <a:tcPr>
-                    <a:solidFill>
-                      <a:srgbClr val="4554C9"/>
-                    </a:solidFill>
-                  </a:tcPr>
-                </a:tc>
-                <a:tc>
-                  <a:txBody>
-                    <a:bodyPr/>
-                    <a:lstStyle/>
-                    <a:p>
-                      <a:pPr algn="l"/>
-                      <a:r>
-                        <a:rPr sz="1200" b="1">
-                          <a:solidFill>
-                            <a:srgbClr val="FFFFFF"/>
-                          </a:solidFill>
-                          <a:latin typeface="Calibri"/>
-                        </a:rPr>
-                        <a:t>What I measured</a:t>
-                      </a:r>
-                    </a:p>
-                  </a:txBody>
-                  <a:tcPr>
-                    <a:solidFill>
-                      <a:srgbClr val="4554C9"/>
-                    </a:solidFill>
-                  </a:tcPr>
-                </a:tc>
-                <a:tc>
-                  <a:txBody>
-                    <a:bodyPr/>
-                    <a:lstStyle/>
-                    <a:p>
-                      <a:pPr algn="ctr"/>
-                      <a:r>
-                        <a:rPr sz="1200" b="1">
-                          <a:solidFill>
-                            <a:srgbClr val="FFFFFF"/>
-                          </a:solidFill>
-                          <a:latin typeface="Calibri"/>
-                        </a:rPr>
-                        <a:t>Start / no memory</a:t>
-                      </a:r>
-                    </a:p>
-                  </a:txBody>
-                  <a:tcPr>
-                    <a:solidFill>
-                      <a:srgbClr val="4554C9"/>
-                    </a:solidFill>
-                  </a:tcPr>
-                </a:tc>
-                <a:tc>
-                  <a:txBody>
-                    <a:bodyPr/>
-                    <a:lstStyle/>
-                    <a:p>
-                      <a:pPr algn="ctr"/>
-                      <a:r>
-                        <a:rPr sz="1200" b="1">
-                          <a:solidFill>
-                            <a:srgbClr val="FFFFFF"/>
-                          </a:solidFill>
-                          <a:latin typeface="Calibri"/>
-                        </a:rPr>
-                        <a:t>Evolved / under pressure</a:t>
-                      </a:r>
-                    </a:p>
-                  </a:txBody>
-                  <a:tcPr>
-                    <a:solidFill>
-                      <a:srgbClr val="4554C9"/>
-                    </a:solidFill>
-                  </a:tcPr>
-                </a:tc>
-              </a:tr>
-              <a:tr h="658368">
-                <a:tc>
-                  <a:txBody>
-                    <a:bodyPr/>
-                    <a:lstStyle/>
-                    <a:p>
-                      <a:pPr algn="l"/>
-                      <a:r>
-                        <a:rPr sz="1250" b="1">
-                          <a:solidFill>
-                            <a:srgbClr val="16213E"/>
-                          </a:solidFill>
-                          <a:latin typeface="Calibri"/>
-                        </a:rPr>
-                        <a:t>Evaluator loop</a:t>
-                      </a:r>
-                    </a:p>
-                  </a:txBody>
-                  <a:tcPr>
-                    <a:solidFill>
-                      <a:srgbClr val="FFFFFF"/>
-                    </a:solidFill>
-                  </a:tcPr>
-                </a:tc>
-                <a:tc>
-                  <a:txBody>
-                    <a:bodyPr/>
-                    <a:lstStyle/>
-                    <a:p>
-                      <a:pPr algn="l"/>
-                      <a:r>
-                        <a:rPr sz="1250">
-                          <a:solidFill>
-                            <a:srgbClr val="282C35"/>
-                          </a:solidFill>
-                          <a:latin typeface="Calibri"/>
-                        </a:rPr>
-                        <a:t>accepts a clearly-WRONG answer</a:t>
-                      </a:r>
-                    </a:p>
-                  </a:txBody>
-                  <a:tcPr>
-                    <a:solidFill>
-                      <a:srgbClr val="FFFFFF"/>
-                    </a:solidFill>
-                  </a:tcPr>
-                </a:tc>
-                <a:tc>
-                  <a:txBody>
-                    <a:bodyPr/>
-                    <a:lstStyle/>
-                    <a:p>
-                      <a:pPr algn="ctr"/>
-                      <a:r>
-                        <a:rPr sz="1250">
-                          <a:solidFill>
-                            <a:srgbClr val="2E7D5B"/>
-                          </a:solidFill>
-                          <a:latin typeface="Calibri"/>
-                        </a:rPr>
-                        <a:t>17%</a:t>
-                      </a:r>
-                    </a:p>
-                  </a:txBody>
-                  <a:tcPr>
-                    <a:solidFill>
-                      <a:srgbClr val="FFFFFF"/>
-                    </a:solidFill>
-                  </a:tcPr>
-                </a:tc>
-                <a:tc>
-                  <a:txBody>
-                    <a:bodyPr/>
-                    <a:lstStyle/>
-                    <a:p>
-                      <a:pPr algn="ctr"/>
-                      <a:r>
-                        <a:rPr sz="1250" b="1">
-                          <a:solidFill>
-                            <a:srgbClr val="C0392B"/>
-                          </a:solidFill>
-                          <a:latin typeface="Calibri"/>
-                        </a:rPr>
-                        <a:t>83%</a:t>
-                      </a:r>
-                    </a:p>
-                  </a:txBody>
-                  <a:tcPr>
-                    <a:solidFill>
-                      <a:srgbClr val="FFFFFF"/>
-                    </a:solidFill>
-                  </a:tcPr>
-                </a:tc>
-              </a:tr>
-              <a:tr h="658368">
-                <a:tc>
-                  <a:txBody>
-                    <a:bodyPr/>
-                    <a:lstStyle/>
-                    <a:p>
-                      <a:pPr algn="l"/>
-                      <a:r>
-                        <a:rPr sz="1250" b="1">
-                          <a:solidFill>
-                            <a:srgbClr val="16213E"/>
-                          </a:solidFill>
-                          <a:latin typeface="Calibri"/>
-                        </a:rPr>
-                        <a:t>Multi-agent (social)</a:t>
-                      </a:r>
-                    </a:p>
-                  </a:txBody>
-                  <a:tcPr>
-                    <a:solidFill>
-                      <a:srgbClr val="F4F5F7"/>
-                    </a:solidFill>
-                  </a:tcPr>
-                </a:tc>
-                <a:tc>
-                  <a:txBody>
-                    <a:bodyPr/>
-                    <a:lstStyle/>
-                    <a:p>
-                      <a:pPr algn="l"/>
-                      <a:r>
-                        <a:rPr sz="1250">
-                          <a:solidFill>
-                            <a:srgbClr val="282C35"/>
-                          </a:solidFill>
-                          <a:latin typeface="Calibri"/>
-                        </a:rPr>
-                        <a:t>approves KNOWN-FLAWED work</a:t>
-                      </a:r>
-                    </a:p>
-                  </a:txBody>
-                  <a:tcPr>
-                    <a:solidFill>
-                      <a:srgbClr val="F4F5F7"/>
-                    </a:solidFill>
-                  </a:tcPr>
-                </a:tc>
-                <a:tc>
-                  <a:txBody>
-                    <a:bodyPr/>
-                    <a:lstStyle/>
-                    <a:p>
-                      <a:pPr algn="ctr"/>
-                      <a:r>
-                        <a:rPr sz="1250">
-                          <a:solidFill>
-                            <a:srgbClr val="2E7D5B"/>
-                          </a:solidFill>
-                          <a:latin typeface="Calibri"/>
-                        </a:rPr>
-                        <a:t>0%</a:t>
-                      </a:r>
-                    </a:p>
-                  </a:txBody>
-                  <a:tcPr>
-                    <a:solidFill>
-                      <a:srgbClr val="F4F5F7"/>
-                    </a:solidFill>
-                  </a:tcPr>
-                </a:tc>
-                <a:tc>
-                  <a:txBody>
-                    <a:bodyPr/>
-                    <a:lstStyle/>
-                    <a:p>
-                      <a:pPr algn="ctr"/>
-                      <a:r>
-                        <a:rPr sz="1250" b="1">
-                          <a:solidFill>
-                            <a:srgbClr val="C0392B"/>
-                          </a:solidFill>
-                          <a:latin typeface="Calibri"/>
-                        </a:rPr>
-                        <a:t>100%</a:t>
-                      </a:r>
-                    </a:p>
-                  </a:txBody>
-                  <a:tcPr>
-                    <a:solidFill>
-                      <a:srgbClr val="F4F5F7"/>
-                    </a:solidFill>
-                  </a:tcPr>
-                </a:tc>
-              </a:tr>
-              <a:tr h="658368">
-                <a:tc>
-                  <a:txBody>
-                    <a:bodyPr/>
-                    <a:lstStyle/>
-                    <a:p>
-                      <a:pPr algn="l"/>
-                      <a:r>
-                        <a:rPr sz="1250" b="1">
-                          <a:solidFill>
-                            <a:srgbClr val="16213E"/>
-                          </a:solidFill>
-                          <a:latin typeface="Calibri"/>
-                        </a:rPr>
-                        <a:t>Goal drift</a:t>
-                      </a:r>
-                    </a:p>
-                  </a:txBody>
-                  <a:tcPr>
-                    <a:solidFill>
-                      <a:srgbClr val="FFFFFF"/>
-                    </a:solidFill>
-                  </a:tcPr>
-                </a:tc>
-                <a:tc>
-                  <a:txBody>
-                    <a:bodyPr/>
-                    <a:lstStyle/>
-                    <a:p>
-                      <a:pPr algn="l"/>
-                      <a:r>
-                        <a:rPr sz="1250">
-                          <a:solidFill>
-                            <a:srgbClr val="282C35"/>
-                          </a:solidFill>
-                          <a:latin typeface="Calibri"/>
-                        </a:rPr>
-                        <a:t>holds its assigned goal</a:t>
-                      </a:r>
-                    </a:p>
-                  </a:txBody>
-                  <a:tcPr>
-                    <a:solidFill>
-                      <a:srgbClr val="FFFFFF"/>
-                    </a:solidFill>
-                  </a:tcPr>
-                </a:tc>
-                <a:tc>
-                  <a:txBody>
-                    <a:bodyPr/>
-                    <a:lstStyle/>
-                    <a:p>
-                      <a:pPr algn="ctr"/>
-                      <a:r>
-                        <a:rPr sz="1250">
-                          <a:solidFill>
-                            <a:srgbClr val="2E7D5B"/>
-                          </a:solidFill>
-                          <a:latin typeface="Calibri"/>
-                        </a:rPr>
-                        <a:t>100%  (turn 1)</a:t>
-                      </a:r>
-                    </a:p>
-                  </a:txBody>
-                  <a:tcPr>
-                    <a:solidFill>
-                      <a:srgbClr val="FFFFFF"/>
-                    </a:solidFill>
-                  </a:tcPr>
-                </a:tc>
-                <a:tc>
-                  <a:txBody>
-                    <a:bodyPr/>
-                    <a:lstStyle/>
-                    <a:p>
-                      <a:pPr algn="ctr"/>
-                      <a:r>
-                        <a:rPr sz="1250" b="1">
-                          <a:solidFill>
-                            <a:srgbClr val="C0392B"/>
-                          </a:solidFill>
-                          <a:latin typeface="Calibri"/>
-                        </a:rPr>
-                        <a:t>33%  (12 turns)</a:t>
-                      </a:r>
-                    </a:p>
-                  </a:txBody>
-                  <a:tcPr>
-                    <a:solidFill>
-                      <a:srgbClr val="FFFFFF"/>
-                    </a:solidFill>
-                  </a:tcPr>
-                </a:tc>
-              </a:tr>
-            </a:tbl>
-          </a:graphicData>
-        </a:graphic>
-      </p:graphicFrame>
+      <p:pic>
+        <p:nvPicPr>
+          <p:cNvPr id="6" name="Picture 5" descr="fig_summary.png"/>
+          <p:cNvPicPr>
+            <a:picLocks noChangeAspect="1"/>
+          </p:cNvPicPr>
+          <p:nvPr/>
+        </p:nvPicPr>
+        <p:blipFill>
+          <a:blip r:embed="rId2"/>
+          <a:stretch>
+            <a:fillRect/>
+          </a:stretch>
+        </p:blipFill>
+        <p:spPr>
+          <a:xfrm>
+            <a:off x="502920" y="1691640"/>
+            <a:ext cx="6400800" cy="3730752"/>
+          </a:xfrm>
+          <a:prstGeom prst="rect">
+            <a:avLst/>
+          </a:prstGeom>
+        </p:spPr>
+      </p:pic>
       <p:sp>
         <p:nvSpPr>
           <p:cNvPr id="7" name="Rectangle 6"/>
@@ -21955,8 +20575,8 @@
         </p:nvSpPr>
         <p:spPr>
           <a:xfrm>
-            <a:off x="548640" y="4343400"/>
-            <a:ext cx="11064240" cy="1965960"/>
+            <a:off x="7086600" y="1691640"/>
+            <a:ext cx="4526280" cy="3749039"/>
           </a:xfrm>
           <a:prstGeom prst="rect">
             <a:avLst/>
@@ -21999,8 +20619,8 @@
         </p:nvSpPr>
         <p:spPr>
           <a:xfrm>
-            <a:off x="777240" y="4498848"/>
-            <a:ext cx="10607040" cy="365760"/>
+            <a:off x="7315200" y="1847088"/>
+            <a:ext cx="4114800" cy="365760"/>
           </a:xfrm>
           <a:prstGeom prst="rect">
             <a:avLst/>
@@ -22015,7 +20635,7 @@
           <a:p>
             <a:pPr algn="l"/>
             <a:r>
-              <a:rPr sz="1250" b="1" i="0">
+              <a:rPr sz="1200" b="1" i="0">
                 <a:solidFill>
                   <a:srgbClr val="4554C9"/>
                 </a:solidFill>
@@ -22034,8 +20654,8 @@
         </p:nvSpPr>
         <p:spPr>
           <a:xfrm>
-            <a:off x="777240" y="4892040"/>
-            <a:ext cx="10607040" cy="1371600"/>
+            <a:off x="7315200" y="2331720"/>
+            <a:ext cx="4114800" cy="3017520"/>
           </a:xfrm>
           <a:prstGeom prst="rect">
             <a:avLst/>
@@ -22050,11 +20670,11 @@
           <a:p>
             <a:pPr>
               <a:spcAft>
-                <a:spcPts val="600"/>
+                <a:spcPts val="1000"/>
               </a:spcAft>
             </a:pPr>
             <a:r>
-              <a:rPr sz="1250" b="1">
+              <a:rPr sz="1150" b="1">
                 <a:solidFill>
                   <a:srgbClr val="4554C9"/>
                 </a:solidFill>
@@ -22063,7 +20683,7 @@
               <a:t>▪  </a:t>
             </a:r>
             <a:r>
-              <a:rPr sz="1250">
+              <a:rPr sz="1150">
                 <a:solidFill>
                   <a:srgbClr val="282C35"/>
                 </a:solidFill>
@@ -22075,11 +20695,11 @@
           <a:p>
             <a:pPr>
               <a:spcAft>
-                <a:spcPts val="600"/>
+                <a:spcPts val="1000"/>
               </a:spcAft>
             </a:pPr>
             <a:r>
-              <a:rPr sz="1250" b="1">
+              <a:rPr sz="1150" b="1">
                 <a:solidFill>
                   <a:srgbClr val="4554C9"/>
                 </a:solidFill>
@@ -22088,7 +20708,7 @@
               <a:t>▪  </a:t>
             </a:r>
             <a:r>
-              <a:rPr sz="1250">
+              <a:rPr sz="1150">
                 <a:solidFill>
                   <a:srgbClr val="282C35"/>
                 </a:solidFill>
@@ -22100,11 +20720,11 @@
           <a:p>
             <a:pPr>
               <a:spcAft>
-                <a:spcPts val="600"/>
+                <a:spcPts val="1000"/>
               </a:spcAft>
             </a:pPr>
             <a:r>
-              <a:rPr sz="1250" b="1">
+              <a:rPr sz="1150" b="1">
                 <a:solidFill>
                   <a:srgbClr val="4554C9"/>
                 </a:solidFill>
@@ -22113,7 +20733,7 @@
               <a:t>▪  </a:t>
             </a:r>
             <a:r>
-              <a:rPr sz="1250">
+              <a:rPr sz="1150">
                 <a:solidFill>
                   <a:srgbClr val="282C35"/>
                 </a:solidFill>

</xml_diff>

<commit_message>
Research-lineage slide: add arXiv links under each paper (repo link for OURS nodes)
</commit_message>
<xml_diff>
--- a/Misevolution_BTP_Presentation.pptx
+++ b/Misevolution_BTP_Presentation.pptx
@@ -22249,8 +22249,8 @@
         </p:nvSpPr>
         <p:spPr>
           <a:xfrm>
-            <a:off x="548640" y="1737360"/>
-            <a:ext cx="1874519" cy="822960"/>
+            <a:off x="548640" y="1691640"/>
+            <a:ext cx="1874519" cy="914400"/>
           </a:xfrm>
           <a:prstGeom prst="rect">
             <a:avLst/>
@@ -22293,8 +22293,8 @@
         </p:nvSpPr>
         <p:spPr>
           <a:xfrm>
-            <a:off x="548640" y="1737360"/>
-            <a:ext cx="1874519" cy="822960"/>
+            <a:off x="548640" y="1691640"/>
+            <a:ext cx="1874519" cy="914400"/>
           </a:xfrm>
           <a:prstGeom prst="rect">
             <a:avLst/>
@@ -22328,8 +22328,8 @@
         </p:nvSpPr>
         <p:spPr>
           <a:xfrm>
-            <a:off x="2606040" y="1737360"/>
-            <a:ext cx="1609344" cy="822960"/>
+            <a:off x="2606040" y="1691640"/>
+            <a:ext cx="1609344" cy="914400"/>
           </a:xfrm>
           <a:prstGeom prst="rect">
             <a:avLst/>
@@ -22372,7 +22372,7 @@
         </p:nvSpPr>
         <p:spPr>
           <a:xfrm>
-            <a:off x="2606040" y="1737360"/>
+            <a:off x="2606040" y="1691640"/>
             <a:ext cx="1609344" cy="64008"/>
           </a:xfrm>
           <a:prstGeom prst="rect">
@@ -22416,8 +22416,8 @@
         </p:nvSpPr>
         <p:spPr>
           <a:xfrm>
-            <a:off x="2642616" y="1828800"/>
-            <a:ext cx="1536192" cy="475488"/>
+            <a:off x="2642616" y="1764792"/>
+            <a:ext cx="1536192" cy="384048"/>
           </a:xfrm>
           <a:prstGeom prst="rect">
             <a:avLst/>
@@ -22451,8 +22451,44 @@
         </p:nvSpPr>
         <p:spPr>
           <a:xfrm>
-            <a:off x="2642616" y="2313432"/>
-            <a:ext cx="1536192" cy="219456"/>
+            <a:off x="2642616" y="2167128"/>
+            <a:ext cx="1536192" cy="182880"/>
+          </a:xfrm>
+          <a:prstGeom prst="rect">
+            <a:avLst/>
+          </a:prstGeom>
+          <a:noFill/>
+        </p:spPr>
+        <p:txBody>
+          <a:bodyPr wrap="square" lIns="0" rIns="0" tIns="0" bIns="0">
+            <a:spAutoFit/>
+          </a:bodyPr>
+          <a:lstStyle/>
+          <a:p>
+            <a:pPr algn="ctr"/>
+            <a:r>
+              <a:rPr sz="750" u="sng">
+                <a:solidFill>
+                  <a:srgbClr val="1155CC"/>
+                </a:solidFill>
+                <a:latin typeface="Calibri"/>
+                <a:hlinkClick r:id="rId2"/>
+              </a:rPr>
+              <a:t>2502.14143</a:t>
+            </a:r>
+          </a:p>
+        </p:txBody>
+      </p:sp>
+      <p:sp>
+        <p:nvSpPr>
+          <p:cNvPr id="12" name="TextBox 11"/>
+          <p:cNvSpPr txBox="1"/>
+          <p:nvPr/>
+        </p:nvSpPr>
+        <p:spPr>
+          <a:xfrm>
+            <a:off x="2642616" y="2368296"/>
+            <a:ext cx="1536192" cy="201168"/>
           </a:xfrm>
           <a:prstGeom prst="rect">
             <a:avLst/>
@@ -22467,7 +22503,7 @@
           <a:p>
             <a:pPr algn="ctr"/>
             <a:r>
-              <a:rPr sz="800" b="0" i="0">
+              <a:rPr sz="750" b="0" i="0">
                 <a:solidFill>
                   <a:srgbClr val="5A616B"/>
                 </a:solidFill>
@@ -22480,14 +22516,14 @@
       </p:sp>
       <p:sp>
         <p:nvSpPr>
-          <p:cNvPr id="12" name="Rectangle 11"/>
+          <p:cNvPr id="13" name="Rectangle 12"/>
           <p:cNvSpPr/>
           <p:nvPr/>
         </p:nvSpPr>
         <p:spPr>
           <a:xfrm>
-            <a:off x="4453128" y="1737360"/>
-            <a:ext cx="1609344" cy="822960"/>
+            <a:off x="4453128" y="1691640"/>
+            <a:ext cx="1609344" cy="914400"/>
           </a:xfrm>
           <a:prstGeom prst="rect">
             <a:avLst/>
@@ -22524,13 +22560,13 @@
       </p:sp>
       <p:sp>
         <p:nvSpPr>
-          <p:cNvPr id="13" name="Rectangle 12"/>
+          <p:cNvPr id="14" name="Rectangle 13"/>
           <p:cNvSpPr/>
           <p:nvPr/>
         </p:nvSpPr>
         <p:spPr>
           <a:xfrm>
-            <a:off x="4453128" y="1737360"/>
+            <a:off x="4453128" y="1691640"/>
             <a:ext cx="1609344" cy="64008"/>
           </a:xfrm>
           <a:prstGeom prst="rect">
@@ -22568,14 +22604,14 @@
       </p:sp>
       <p:sp>
         <p:nvSpPr>
-          <p:cNvPr id="14" name="TextBox 13"/>
-          <p:cNvSpPr txBox="1"/>
-          <p:nvPr/>
-        </p:nvSpPr>
-        <p:spPr>
-          <a:xfrm>
-            <a:off x="4489704" y="1828800"/>
-            <a:ext cx="1536192" cy="475488"/>
+          <p:cNvPr id="15" name="TextBox 14"/>
+          <p:cNvSpPr txBox="1"/>
+          <p:nvPr/>
+        </p:nvSpPr>
+        <p:spPr>
+          <a:xfrm>
+            <a:off x="4489704" y="1764792"/>
+            <a:ext cx="1536192" cy="384048"/>
           </a:xfrm>
           <a:prstGeom prst="rect">
             <a:avLst/>
@@ -22603,14 +22639,50 @@
       </p:sp>
       <p:sp>
         <p:nvSpPr>
-          <p:cNvPr id="15" name="TextBox 14"/>
-          <p:cNvSpPr txBox="1"/>
-          <p:nvPr/>
-        </p:nvSpPr>
-        <p:spPr>
-          <a:xfrm>
-            <a:off x="4489704" y="2313432"/>
-            <a:ext cx="1536192" cy="219456"/>
+          <p:cNvPr id="16" name="TextBox 15"/>
+          <p:cNvSpPr txBox="1"/>
+          <p:nvPr/>
+        </p:nvSpPr>
+        <p:spPr>
+          <a:xfrm>
+            <a:off x="4489704" y="2167128"/>
+            <a:ext cx="1536192" cy="182880"/>
+          </a:xfrm>
+          <a:prstGeom prst="rect">
+            <a:avLst/>
+          </a:prstGeom>
+          <a:noFill/>
+        </p:spPr>
+        <p:txBody>
+          <a:bodyPr wrap="square" lIns="0" rIns="0" tIns="0" bIns="0">
+            <a:spAutoFit/>
+          </a:bodyPr>
+          <a:lstStyle/>
+          <a:p>
+            <a:pPr algn="ctr"/>
+            <a:r>
+              <a:rPr sz="750" u="sng">
+                <a:solidFill>
+                  <a:srgbClr val="1155CC"/>
+                </a:solidFill>
+                <a:latin typeface="Calibri"/>
+                <a:hlinkClick r:id="rId3"/>
+              </a:rPr>
+              <a:t>2510.04860</a:t>
+            </a:r>
+          </a:p>
+        </p:txBody>
+      </p:sp>
+      <p:sp>
+        <p:nvSpPr>
+          <p:cNvPr id="17" name="TextBox 16"/>
+          <p:cNvSpPr txBox="1"/>
+          <p:nvPr/>
+        </p:nvSpPr>
+        <p:spPr>
+          <a:xfrm>
+            <a:off x="4489704" y="2368296"/>
+            <a:ext cx="1536192" cy="201168"/>
           </a:xfrm>
           <a:prstGeom prst="rect">
             <a:avLst/>
@@ -22625,7 +22697,7 @@
           <a:p>
             <a:pPr algn="ctr"/>
             <a:r>
-              <a:rPr sz="800" b="0" i="0">
+              <a:rPr sz="750" b="0" i="0">
                 <a:solidFill>
                   <a:srgbClr val="5A616B"/>
                 </a:solidFill>
@@ -22638,13 +22710,13 @@
       </p:sp>
       <p:sp>
         <p:nvSpPr>
-          <p:cNvPr id="16" name="TextBox 15"/>
-          <p:cNvSpPr txBox="1"/>
-          <p:nvPr/>
-        </p:nvSpPr>
-        <p:spPr>
-          <a:xfrm>
-            <a:off x="4210812" y="1883664"/>
+          <p:cNvPr id="18" name="TextBox 17"/>
+          <p:cNvSpPr txBox="1"/>
+          <p:nvPr/>
+        </p:nvSpPr>
+        <p:spPr>
+          <a:xfrm>
+            <a:off x="4210812" y="1911095"/>
             <a:ext cx="274320" cy="457200"/>
           </a:xfrm>
           <a:prstGeom prst="rect">
@@ -22673,14 +22745,14 @@
       </p:sp>
       <p:sp>
         <p:nvSpPr>
-          <p:cNvPr id="17" name="Rectangle 16"/>
+          <p:cNvPr id="19" name="Rectangle 18"/>
           <p:cNvSpPr/>
           <p:nvPr/>
         </p:nvSpPr>
         <p:spPr>
           <a:xfrm>
-            <a:off x="6300216" y="1737360"/>
-            <a:ext cx="1609344" cy="822960"/>
+            <a:off x="6300216" y="1691640"/>
+            <a:ext cx="1609344" cy="914400"/>
           </a:xfrm>
           <a:prstGeom prst="rect">
             <a:avLst/>
@@ -22717,13 +22789,13 @@
       </p:sp>
       <p:sp>
         <p:nvSpPr>
-          <p:cNvPr id="18" name="Rectangle 17"/>
+          <p:cNvPr id="20" name="Rectangle 19"/>
           <p:cNvSpPr/>
           <p:nvPr/>
         </p:nvSpPr>
         <p:spPr>
           <a:xfrm>
-            <a:off x="6300216" y="1737360"/>
+            <a:off x="6300216" y="1691640"/>
             <a:ext cx="1609344" cy="64008"/>
           </a:xfrm>
           <a:prstGeom prst="rect">
@@ -22761,14 +22833,14 @@
       </p:sp>
       <p:sp>
         <p:nvSpPr>
-          <p:cNvPr id="19" name="TextBox 18"/>
-          <p:cNvSpPr txBox="1"/>
-          <p:nvPr/>
-        </p:nvSpPr>
-        <p:spPr>
-          <a:xfrm>
-            <a:off x="6336792" y="1828800"/>
-            <a:ext cx="1536192" cy="475488"/>
+          <p:cNvPr id="21" name="TextBox 20"/>
+          <p:cNvSpPr txBox="1"/>
+          <p:nvPr/>
+        </p:nvSpPr>
+        <p:spPr>
+          <a:xfrm>
+            <a:off x="6336792" y="1764792"/>
+            <a:ext cx="1536192" cy="384048"/>
           </a:xfrm>
           <a:prstGeom prst="rect">
             <a:avLst/>
@@ -22796,14 +22868,50 @@
       </p:sp>
       <p:sp>
         <p:nvSpPr>
-          <p:cNvPr id="20" name="TextBox 19"/>
-          <p:cNvSpPr txBox="1"/>
-          <p:nvPr/>
-        </p:nvSpPr>
-        <p:spPr>
-          <a:xfrm>
-            <a:off x="6336792" y="2313432"/>
-            <a:ext cx="1536192" cy="219456"/>
+          <p:cNvPr id="22" name="TextBox 21"/>
+          <p:cNvSpPr txBox="1"/>
+          <p:nvPr/>
+        </p:nvSpPr>
+        <p:spPr>
+          <a:xfrm>
+            <a:off x="6336792" y="2167128"/>
+            <a:ext cx="1536192" cy="182880"/>
+          </a:xfrm>
+          <a:prstGeom prst="rect">
+            <a:avLst/>
+          </a:prstGeom>
+          <a:noFill/>
+        </p:spPr>
+        <p:txBody>
+          <a:bodyPr wrap="square" lIns="0" rIns="0" tIns="0" bIns="0">
+            <a:spAutoFit/>
+          </a:bodyPr>
+          <a:lstStyle/>
+          <a:p>
+            <a:pPr algn="ctr"/>
+            <a:r>
+              <a:rPr sz="750" u="sng">
+                <a:solidFill>
+                  <a:srgbClr val="1155CC"/>
+                </a:solidFill>
+                <a:latin typeface="Calibri"/>
+                <a:hlinkClick r:id="rId4"/>
+              </a:rPr>
+              <a:t>2609.24967</a:t>
+            </a:r>
+          </a:p>
+        </p:txBody>
+      </p:sp>
+      <p:sp>
+        <p:nvSpPr>
+          <p:cNvPr id="23" name="TextBox 22"/>
+          <p:cNvSpPr txBox="1"/>
+          <p:nvPr/>
+        </p:nvSpPr>
+        <p:spPr>
+          <a:xfrm>
+            <a:off x="6336792" y="2368296"/>
+            <a:ext cx="1536192" cy="201168"/>
           </a:xfrm>
           <a:prstGeom prst="rect">
             <a:avLst/>
@@ -22818,7 +22926,7 @@
           <a:p>
             <a:pPr algn="ctr"/>
             <a:r>
-              <a:rPr sz="800" b="0" i="0">
+              <a:rPr sz="750" b="0" i="0">
                 <a:solidFill>
                   <a:srgbClr val="5A616B"/>
                 </a:solidFill>
@@ -22831,13 +22939,13 @@
       </p:sp>
       <p:sp>
         <p:nvSpPr>
-          <p:cNvPr id="21" name="TextBox 20"/>
-          <p:cNvSpPr txBox="1"/>
-          <p:nvPr/>
-        </p:nvSpPr>
-        <p:spPr>
-          <a:xfrm>
-            <a:off x="6057900" y="1883664"/>
+          <p:cNvPr id="24" name="TextBox 23"/>
+          <p:cNvSpPr txBox="1"/>
+          <p:nvPr/>
+        </p:nvSpPr>
+        <p:spPr>
+          <a:xfrm>
+            <a:off x="6057900" y="1911095"/>
             <a:ext cx="274320" cy="457200"/>
           </a:xfrm>
           <a:prstGeom prst="rect">
@@ -22866,14 +22974,14 @@
       </p:sp>
       <p:sp>
         <p:nvSpPr>
-          <p:cNvPr id="22" name="Rectangle 21"/>
+          <p:cNvPr id="25" name="Rectangle 24"/>
           <p:cNvSpPr/>
           <p:nvPr/>
         </p:nvSpPr>
         <p:spPr>
           <a:xfrm>
-            <a:off x="8147304" y="1737360"/>
-            <a:ext cx="1609344" cy="822960"/>
+            <a:off x="8147304" y="1691640"/>
+            <a:ext cx="1609344" cy="914400"/>
           </a:xfrm>
           <a:prstGeom prst="rect">
             <a:avLst/>
@@ -22910,13 +23018,13 @@
       </p:sp>
       <p:sp>
         <p:nvSpPr>
-          <p:cNvPr id="23" name="Rectangle 22"/>
+          <p:cNvPr id="26" name="Rectangle 25"/>
           <p:cNvSpPr/>
           <p:nvPr/>
         </p:nvSpPr>
         <p:spPr>
           <a:xfrm>
-            <a:off x="8147304" y="1737360"/>
+            <a:off x="8147304" y="1691640"/>
             <a:ext cx="1609344" cy="64008"/>
           </a:xfrm>
           <a:prstGeom prst="rect">
@@ -22954,14 +23062,14 @@
       </p:sp>
       <p:sp>
         <p:nvSpPr>
-          <p:cNvPr id="24" name="TextBox 23"/>
-          <p:cNvSpPr txBox="1"/>
-          <p:nvPr/>
-        </p:nvSpPr>
-        <p:spPr>
-          <a:xfrm>
-            <a:off x="8183879" y="1828800"/>
-            <a:ext cx="1536192" cy="475488"/>
+          <p:cNvPr id="27" name="TextBox 26"/>
+          <p:cNvSpPr txBox="1"/>
+          <p:nvPr/>
+        </p:nvSpPr>
+        <p:spPr>
+          <a:xfrm>
+            <a:off x="8183879" y="1764792"/>
+            <a:ext cx="1536192" cy="384048"/>
           </a:xfrm>
           <a:prstGeom prst="rect">
             <a:avLst/>
@@ -22989,14 +23097,50 @@
       </p:sp>
       <p:sp>
         <p:nvSpPr>
-          <p:cNvPr id="25" name="TextBox 24"/>
-          <p:cNvSpPr txBox="1"/>
-          <p:nvPr/>
-        </p:nvSpPr>
-        <p:spPr>
-          <a:xfrm>
-            <a:off x="8183879" y="2313432"/>
-            <a:ext cx="1536192" cy="219456"/>
+          <p:cNvPr id="28" name="TextBox 27"/>
+          <p:cNvSpPr txBox="1"/>
+          <p:nvPr/>
+        </p:nvSpPr>
+        <p:spPr>
+          <a:xfrm>
+            <a:off x="8183879" y="2167128"/>
+            <a:ext cx="1536192" cy="182880"/>
+          </a:xfrm>
+          <a:prstGeom prst="rect">
+            <a:avLst/>
+          </a:prstGeom>
+          <a:noFill/>
+        </p:spPr>
+        <p:txBody>
+          <a:bodyPr wrap="square" lIns="0" rIns="0" tIns="0" bIns="0">
+            <a:spAutoFit/>
+          </a:bodyPr>
+          <a:lstStyle/>
+          <a:p>
+            <a:pPr algn="ctr"/>
+            <a:r>
+              <a:rPr sz="750" u="sng">
+                <a:solidFill>
+                  <a:srgbClr val="1155CC"/>
+                </a:solidFill>
+                <a:latin typeface="Calibri"/>
+                <a:hlinkClick r:id="rId5"/>
+              </a:rPr>
+              <a:t>2609.00595</a:t>
+            </a:r>
+          </a:p>
+        </p:txBody>
+      </p:sp>
+      <p:sp>
+        <p:nvSpPr>
+          <p:cNvPr id="29" name="TextBox 28"/>
+          <p:cNvSpPr txBox="1"/>
+          <p:nvPr/>
+        </p:nvSpPr>
+        <p:spPr>
+          <a:xfrm>
+            <a:off x="8183879" y="2368296"/>
+            <a:ext cx="1536192" cy="201168"/>
           </a:xfrm>
           <a:prstGeom prst="rect">
             <a:avLst/>
@@ -23011,7 +23155,7 @@
           <a:p>
             <a:pPr algn="ctr"/>
             <a:r>
-              <a:rPr sz="800" b="0" i="0">
+              <a:rPr sz="750" b="0" i="0">
                 <a:solidFill>
                   <a:srgbClr val="5A616B"/>
                 </a:solidFill>
@@ -23024,13 +23168,13 @@
       </p:sp>
       <p:sp>
         <p:nvSpPr>
-          <p:cNvPr id="26" name="TextBox 25"/>
-          <p:cNvSpPr txBox="1"/>
-          <p:nvPr/>
-        </p:nvSpPr>
-        <p:spPr>
-          <a:xfrm>
-            <a:off x="7904988" y="1883664"/>
+          <p:cNvPr id="30" name="TextBox 29"/>
+          <p:cNvSpPr txBox="1"/>
+          <p:nvPr/>
+        </p:nvSpPr>
+        <p:spPr>
+          <a:xfrm>
+            <a:off x="7904988" y="1911095"/>
             <a:ext cx="274320" cy="457200"/>
           </a:xfrm>
           <a:prstGeom prst="rect">
@@ -23059,14 +23203,14 @@
       </p:sp>
       <p:sp>
         <p:nvSpPr>
-          <p:cNvPr id="27" name="Rectangle 26"/>
+          <p:cNvPr id="31" name="Rectangle 30"/>
           <p:cNvSpPr/>
           <p:nvPr/>
         </p:nvSpPr>
         <p:spPr>
           <a:xfrm>
-            <a:off x="9994392" y="1737360"/>
-            <a:ext cx="1609344" cy="822960"/>
+            <a:off x="9994392" y="1691640"/>
+            <a:ext cx="1609344" cy="914400"/>
           </a:xfrm>
           <a:prstGeom prst="rect">
             <a:avLst/>
@@ -23103,14 +23247,14 @@
       </p:sp>
       <p:sp>
         <p:nvSpPr>
-          <p:cNvPr id="28" name="TextBox 27"/>
-          <p:cNvSpPr txBox="1"/>
-          <p:nvPr/>
-        </p:nvSpPr>
-        <p:spPr>
-          <a:xfrm>
-            <a:off x="10030967" y="1828800"/>
-            <a:ext cx="1536192" cy="475488"/>
+          <p:cNvPr id="32" name="TextBox 31"/>
+          <p:cNvSpPr txBox="1"/>
+          <p:nvPr/>
+        </p:nvSpPr>
+        <p:spPr>
+          <a:xfrm>
+            <a:off x="10030967" y="1764792"/>
+            <a:ext cx="1536192" cy="384048"/>
           </a:xfrm>
           <a:prstGeom prst="rect">
             <a:avLst/>
@@ -23138,14 +23282,50 @@
       </p:sp>
       <p:sp>
         <p:nvSpPr>
-          <p:cNvPr id="29" name="TextBox 28"/>
-          <p:cNvSpPr txBox="1"/>
-          <p:nvPr/>
-        </p:nvSpPr>
-        <p:spPr>
-          <a:xfrm>
-            <a:off x="10030967" y="2313432"/>
-            <a:ext cx="1536192" cy="219456"/>
+          <p:cNvPr id="33" name="TextBox 32"/>
+          <p:cNvSpPr txBox="1"/>
+          <p:nvPr/>
+        </p:nvSpPr>
+        <p:spPr>
+          <a:xfrm>
+            <a:off x="10030967" y="2167128"/>
+            <a:ext cx="1536192" cy="182880"/>
+          </a:xfrm>
+          <a:prstGeom prst="rect">
+            <a:avLst/>
+          </a:prstGeom>
+          <a:noFill/>
+        </p:spPr>
+        <p:txBody>
+          <a:bodyPr wrap="square" lIns="0" rIns="0" tIns="0" bIns="0">
+            <a:spAutoFit/>
+          </a:bodyPr>
+          <a:lstStyle/>
+          <a:p>
+            <a:pPr algn="ctr"/>
+            <a:r>
+              <a:rPr sz="750" u="sng">
+                <a:solidFill>
+                  <a:srgbClr val="FFFFFF"/>
+                </a:solidFill>
+                <a:latin typeface="Calibri"/>
+                <a:hlinkClick r:id="rId6"/>
+              </a:rPr>
+              <a:t>repo ↗</a:t>
+            </a:r>
+          </a:p>
+        </p:txBody>
+      </p:sp>
+      <p:sp>
+        <p:nvSpPr>
+          <p:cNvPr id="34" name="TextBox 33"/>
+          <p:cNvSpPr txBox="1"/>
+          <p:nvPr/>
+        </p:nvSpPr>
+        <p:spPr>
+          <a:xfrm>
+            <a:off x="10030967" y="2368296"/>
+            <a:ext cx="1536192" cy="201168"/>
           </a:xfrm>
           <a:prstGeom prst="rect">
             <a:avLst/>
@@ -23160,7 +23340,7 @@
           <a:p>
             <a:pPr algn="ctr"/>
             <a:r>
-              <a:rPr sz="800" b="0" i="0">
+              <a:rPr sz="750" b="0" i="0">
                 <a:solidFill>
                   <a:srgbClr val="FFFFFF"/>
                 </a:solidFill>
@@ -23173,13 +23353,13 @@
       </p:sp>
       <p:sp>
         <p:nvSpPr>
-          <p:cNvPr id="30" name="TextBox 29"/>
-          <p:cNvSpPr txBox="1"/>
-          <p:nvPr/>
-        </p:nvSpPr>
-        <p:spPr>
-          <a:xfrm>
-            <a:off x="9752076" y="1883664"/>
+          <p:cNvPr id="35" name="TextBox 34"/>
+          <p:cNvSpPr txBox="1"/>
+          <p:nvPr/>
+        </p:nvSpPr>
+        <p:spPr>
+          <a:xfrm>
+            <a:off x="9752076" y="1911095"/>
             <a:ext cx="274320" cy="457200"/>
           </a:xfrm>
           <a:prstGeom prst="rect">
@@ -23208,14 +23388,14 @@
       </p:sp>
       <p:sp>
         <p:nvSpPr>
-          <p:cNvPr id="31" name="Rectangle 30"/>
+          <p:cNvPr id="36" name="Rectangle 35"/>
           <p:cNvSpPr/>
           <p:nvPr/>
         </p:nvSpPr>
         <p:spPr>
           <a:xfrm>
-            <a:off x="548640" y="3154680"/>
-            <a:ext cx="1874519" cy="822960"/>
+            <a:off x="548640" y="3108960"/>
+            <a:ext cx="1874519" cy="914400"/>
           </a:xfrm>
           <a:prstGeom prst="rect">
             <a:avLst/>
@@ -23252,14 +23432,14 @@
       </p:sp>
       <p:sp>
         <p:nvSpPr>
-          <p:cNvPr id="32" name="TextBox 31"/>
-          <p:cNvSpPr txBox="1"/>
-          <p:nvPr/>
-        </p:nvSpPr>
-        <p:spPr>
-          <a:xfrm>
-            <a:off x="548640" y="3154680"/>
-            <a:ext cx="1874519" cy="822960"/>
+          <p:cNvPr id="37" name="TextBox 36"/>
+          <p:cNvSpPr txBox="1"/>
+          <p:nvPr/>
+        </p:nvSpPr>
+        <p:spPr>
+          <a:xfrm>
+            <a:off x="548640" y="3108960"/>
+            <a:ext cx="1874519" cy="914400"/>
           </a:xfrm>
           <a:prstGeom prst="rect">
             <a:avLst/>
@@ -23287,14 +23467,14 @@
       </p:sp>
       <p:sp>
         <p:nvSpPr>
-          <p:cNvPr id="33" name="Rectangle 32"/>
+          <p:cNvPr id="38" name="Rectangle 37"/>
           <p:cNvSpPr/>
           <p:nvPr/>
         </p:nvSpPr>
         <p:spPr>
           <a:xfrm>
-            <a:off x="2606040" y="3154680"/>
-            <a:ext cx="1301496" cy="822960"/>
+            <a:off x="2606040" y="3108960"/>
+            <a:ext cx="1301496" cy="914400"/>
           </a:xfrm>
           <a:prstGeom prst="rect">
             <a:avLst/>
@@ -23331,13 +23511,13 @@
       </p:sp>
       <p:sp>
         <p:nvSpPr>
-          <p:cNvPr id="34" name="Rectangle 33"/>
+          <p:cNvPr id="39" name="Rectangle 38"/>
           <p:cNvSpPr/>
           <p:nvPr/>
         </p:nvSpPr>
         <p:spPr>
           <a:xfrm>
-            <a:off x="2606040" y="3154680"/>
+            <a:off x="2606040" y="3108960"/>
             <a:ext cx="1301496" cy="64008"/>
           </a:xfrm>
           <a:prstGeom prst="rect">
@@ -23375,14 +23555,14 @@
       </p:sp>
       <p:sp>
         <p:nvSpPr>
-          <p:cNvPr id="35" name="TextBox 34"/>
-          <p:cNvSpPr txBox="1"/>
-          <p:nvPr/>
-        </p:nvSpPr>
-        <p:spPr>
-          <a:xfrm>
-            <a:off x="2642616" y="3246120"/>
-            <a:ext cx="1228344" cy="475488"/>
+          <p:cNvPr id="40" name="TextBox 39"/>
+          <p:cNvSpPr txBox="1"/>
+          <p:nvPr/>
+        </p:nvSpPr>
+        <p:spPr>
+          <a:xfrm>
+            <a:off x="2642616" y="3182112"/>
+            <a:ext cx="1228344" cy="384048"/>
           </a:xfrm>
           <a:prstGeom prst="rect">
             <a:avLst/>
@@ -23410,14 +23590,50 @@
       </p:sp>
       <p:sp>
         <p:nvSpPr>
-          <p:cNvPr id="36" name="TextBox 35"/>
-          <p:cNvSpPr txBox="1"/>
-          <p:nvPr/>
-        </p:nvSpPr>
-        <p:spPr>
-          <a:xfrm>
-            <a:off x="2642616" y="3730752"/>
-            <a:ext cx="1228344" cy="219456"/>
+          <p:cNvPr id="41" name="TextBox 40"/>
+          <p:cNvSpPr txBox="1"/>
+          <p:nvPr/>
+        </p:nvSpPr>
+        <p:spPr>
+          <a:xfrm>
+            <a:off x="2642616" y="3584448"/>
+            <a:ext cx="1228344" cy="182880"/>
+          </a:xfrm>
+          <a:prstGeom prst="rect">
+            <a:avLst/>
+          </a:prstGeom>
+          <a:noFill/>
+        </p:spPr>
+        <p:txBody>
+          <a:bodyPr wrap="square" lIns="0" rIns="0" tIns="0" bIns="0">
+            <a:spAutoFit/>
+          </a:bodyPr>
+          <a:lstStyle/>
+          <a:p>
+            <a:pPr algn="ctr"/>
+            <a:r>
+              <a:rPr sz="750" u="sng">
+                <a:solidFill>
+                  <a:srgbClr val="1155CC"/>
+                </a:solidFill>
+                <a:latin typeface="Calibri"/>
+                <a:hlinkClick r:id="rId7"/>
+              </a:rPr>
+              <a:t>2402.06627</a:t>
+            </a:r>
+          </a:p>
+        </p:txBody>
+      </p:sp>
+      <p:sp>
+        <p:nvSpPr>
+          <p:cNvPr id="42" name="TextBox 41"/>
+          <p:cNvSpPr txBox="1"/>
+          <p:nvPr/>
+        </p:nvSpPr>
+        <p:spPr>
+          <a:xfrm>
+            <a:off x="2642616" y="3785615"/>
+            <a:ext cx="1228344" cy="201168"/>
           </a:xfrm>
           <a:prstGeom prst="rect">
             <a:avLst/>
@@ -23432,7 +23648,7 @@
           <a:p>
             <a:pPr algn="ctr"/>
             <a:r>
-              <a:rPr sz="800" b="0" i="0">
+              <a:rPr sz="750" b="0" i="0">
                 <a:solidFill>
                   <a:srgbClr val="5A616B"/>
                 </a:solidFill>
@@ -23445,14 +23661,14 @@
       </p:sp>
       <p:sp>
         <p:nvSpPr>
-          <p:cNvPr id="37" name="Rectangle 36"/>
+          <p:cNvPr id="43" name="Rectangle 42"/>
           <p:cNvSpPr/>
           <p:nvPr/>
         </p:nvSpPr>
         <p:spPr>
           <a:xfrm>
-            <a:off x="4145280" y="3154680"/>
-            <a:ext cx="1301496" cy="822960"/>
+            <a:off x="4145280" y="3108960"/>
+            <a:ext cx="1301496" cy="914400"/>
           </a:xfrm>
           <a:prstGeom prst="rect">
             <a:avLst/>
@@ -23489,13 +23705,13 @@
       </p:sp>
       <p:sp>
         <p:nvSpPr>
-          <p:cNvPr id="38" name="Rectangle 37"/>
+          <p:cNvPr id="44" name="Rectangle 43"/>
           <p:cNvSpPr/>
           <p:nvPr/>
         </p:nvSpPr>
         <p:spPr>
           <a:xfrm>
-            <a:off x="4145280" y="3154680"/>
+            <a:off x="4145280" y="3108960"/>
             <a:ext cx="1301496" cy="64008"/>
           </a:xfrm>
           <a:prstGeom prst="rect">
@@ -23533,14 +23749,14 @@
       </p:sp>
       <p:sp>
         <p:nvSpPr>
-          <p:cNvPr id="39" name="TextBox 38"/>
-          <p:cNvSpPr txBox="1"/>
-          <p:nvPr/>
-        </p:nvSpPr>
-        <p:spPr>
-          <a:xfrm>
-            <a:off x="4181856" y="3246120"/>
-            <a:ext cx="1228344" cy="475488"/>
+          <p:cNvPr id="45" name="TextBox 44"/>
+          <p:cNvSpPr txBox="1"/>
+          <p:nvPr/>
+        </p:nvSpPr>
+        <p:spPr>
+          <a:xfrm>
+            <a:off x="4181856" y="3182112"/>
+            <a:ext cx="1228344" cy="384048"/>
           </a:xfrm>
           <a:prstGeom prst="rect">
             <a:avLst/>
@@ -23568,14 +23784,50 @@
       </p:sp>
       <p:sp>
         <p:nvSpPr>
-          <p:cNvPr id="40" name="TextBox 39"/>
-          <p:cNvSpPr txBox="1"/>
-          <p:nvPr/>
-        </p:nvSpPr>
-        <p:spPr>
-          <a:xfrm>
-            <a:off x="4181856" y="3730752"/>
-            <a:ext cx="1228344" cy="219456"/>
+          <p:cNvPr id="46" name="TextBox 45"/>
+          <p:cNvSpPr txBox="1"/>
+          <p:nvPr/>
+        </p:nvSpPr>
+        <p:spPr>
+          <a:xfrm>
+            <a:off x="4181856" y="3584448"/>
+            <a:ext cx="1228344" cy="182880"/>
+          </a:xfrm>
+          <a:prstGeom prst="rect">
+            <a:avLst/>
+          </a:prstGeom>
+          <a:noFill/>
+        </p:spPr>
+        <p:txBody>
+          <a:bodyPr wrap="square" lIns="0" rIns="0" tIns="0" bIns="0">
+            <a:spAutoFit/>
+          </a:bodyPr>
+          <a:lstStyle/>
+          <a:p>
+            <a:pPr algn="ctr"/>
+            <a:r>
+              <a:rPr sz="750" u="sng">
+                <a:solidFill>
+                  <a:srgbClr val="1155CC"/>
+                </a:solidFill>
+                <a:latin typeface="Calibri"/>
+                <a:hlinkClick r:id="rId8"/>
+              </a:rPr>
+              <a:t>2407.04549</a:t>
+            </a:r>
+          </a:p>
+        </p:txBody>
+      </p:sp>
+      <p:sp>
+        <p:nvSpPr>
+          <p:cNvPr id="47" name="TextBox 46"/>
+          <p:cNvSpPr txBox="1"/>
+          <p:nvPr/>
+        </p:nvSpPr>
+        <p:spPr>
+          <a:xfrm>
+            <a:off x="4181856" y="3785615"/>
+            <a:ext cx="1228344" cy="201168"/>
           </a:xfrm>
           <a:prstGeom prst="rect">
             <a:avLst/>
@@ -23590,7 +23842,7 @@
           <a:p>
             <a:pPr algn="ctr"/>
             <a:r>
-              <a:rPr sz="800" b="0" i="0">
+              <a:rPr sz="750" b="0" i="0">
                 <a:solidFill>
                   <a:srgbClr val="5A616B"/>
                 </a:solidFill>
@@ -23603,13 +23855,13 @@
       </p:sp>
       <p:sp>
         <p:nvSpPr>
-          <p:cNvPr id="41" name="TextBox 40"/>
-          <p:cNvSpPr txBox="1"/>
-          <p:nvPr/>
-        </p:nvSpPr>
-        <p:spPr>
-          <a:xfrm>
-            <a:off x="3902964" y="3300984"/>
+          <p:cNvPr id="48" name="TextBox 47"/>
+          <p:cNvSpPr txBox="1"/>
+          <p:nvPr/>
+        </p:nvSpPr>
+        <p:spPr>
+          <a:xfrm>
+            <a:off x="3902964" y="3328415"/>
             <a:ext cx="274320" cy="457200"/>
           </a:xfrm>
           <a:prstGeom prst="rect">
@@ -23638,14 +23890,14 @@
       </p:sp>
       <p:sp>
         <p:nvSpPr>
-          <p:cNvPr id="42" name="Rectangle 41"/>
+          <p:cNvPr id="49" name="Rectangle 48"/>
           <p:cNvSpPr/>
           <p:nvPr/>
         </p:nvSpPr>
         <p:spPr>
           <a:xfrm>
-            <a:off x="5684520" y="3154680"/>
-            <a:ext cx="1301496" cy="822960"/>
+            <a:off x="5684520" y="3108960"/>
+            <a:ext cx="1301496" cy="914400"/>
           </a:xfrm>
           <a:prstGeom prst="rect">
             <a:avLst/>
@@ -23682,13 +23934,13 @@
       </p:sp>
       <p:sp>
         <p:nvSpPr>
-          <p:cNvPr id="43" name="Rectangle 42"/>
+          <p:cNvPr id="50" name="Rectangle 49"/>
           <p:cNvSpPr/>
           <p:nvPr/>
         </p:nvSpPr>
         <p:spPr>
           <a:xfrm>
-            <a:off x="5684520" y="3154680"/>
+            <a:off x="5684520" y="3108960"/>
             <a:ext cx="1301496" cy="64008"/>
           </a:xfrm>
           <a:prstGeom prst="rect">
@@ -23726,14 +23978,14 @@
       </p:sp>
       <p:sp>
         <p:nvSpPr>
-          <p:cNvPr id="44" name="TextBox 43"/>
-          <p:cNvSpPr txBox="1"/>
-          <p:nvPr/>
-        </p:nvSpPr>
-        <p:spPr>
-          <a:xfrm>
-            <a:off x="5721096" y="3246120"/>
-            <a:ext cx="1228344" cy="475488"/>
+          <p:cNvPr id="51" name="TextBox 50"/>
+          <p:cNvSpPr txBox="1"/>
+          <p:nvPr/>
+        </p:nvSpPr>
+        <p:spPr>
+          <a:xfrm>
+            <a:off x="5721096" y="3182112"/>
+            <a:ext cx="1228344" cy="384048"/>
           </a:xfrm>
           <a:prstGeom prst="rect">
             <a:avLst/>
@@ -23761,14 +24013,50 @@
       </p:sp>
       <p:sp>
         <p:nvSpPr>
-          <p:cNvPr id="45" name="TextBox 44"/>
-          <p:cNvSpPr txBox="1"/>
-          <p:nvPr/>
-        </p:nvSpPr>
-        <p:spPr>
-          <a:xfrm>
-            <a:off x="5721096" y="3730752"/>
-            <a:ext cx="1228344" cy="219456"/>
+          <p:cNvPr id="52" name="TextBox 51"/>
+          <p:cNvSpPr txBox="1"/>
+          <p:nvPr/>
+        </p:nvSpPr>
+        <p:spPr>
+          <a:xfrm>
+            <a:off x="5721096" y="3584448"/>
+            <a:ext cx="1228344" cy="182880"/>
+          </a:xfrm>
+          <a:prstGeom prst="rect">
+            <a:avLst/>
+          </a:prstGeom>
+          <a:noFill/>
+        </p:spPr>
+        <p:txBody>
+          <a:bodyPr wrap="square" lIns="0" rIns="0" tIns="0" bIns="0">
+            <a:spAutoFit/>
+          </a:bodyPr>
+          <a:lstStyle/>
+          <a:p>
+            <a:pPr algn="ctr"/>
+            <a:r>
+              <a:rPr sz="750" u="sng">
+                <a:solidFill>
+                  <a:srgbClr val="1155CC"/>
+                </a:solidFill>
+                <a:latin typeface="Calibri"/>
+                <a:hlinkClick r:id="rId9"/>
+              </a:rPr>
+              <a:t>2410.06491</a:t>
+            </a:r>
+          </a:p>
+        </p:txBody>
+      </p:sp>
+      <p:sp>
+        <p:nvSpPr>
+          <p:cNvPr id="53" name="TextBox 52"/>
+          <p:cNvSpPr txBox="1"/>
+          <p:nvPr/>
+        </p:nvSpPr>
+        <p:spPr>
+          <a:xfrm>
+            <a:off x="5721096" y="3785615"/>
+            <a:ext cx="1228344" cy="201168"/>
           </a:xfrm>
           <a:prstGeom prst="rect">
             <a:avLst/>
@@ -23783,7 +24071,7 @@
           <a:p>
             <a:pPr algn="ctr"/>
             <a:r>
-              <a:rPr sz="800" b="0" i="0">
+              <a:rPr sz="750" b="0" i="0">
                 <a:solidFill>
                   <a:srgbClr val="5A616B"/>
                 </a:solidFill>
@@ -23796,13 +24084,13 @@
       </p:sp>
       <p:sp>
         <p:nvSpPr>
-          <p:cNvPr id="46" name="TextBox 45"/>
-          <p:cNvSpPr txBox="1"/>
-          <p:nvPr/>
-        </p:nvSpPr>
-        <p:spPr>
-          <a:xfrm>
-            <a:off x="5442204" y="3300984"/>
+          <p:cNvPr id="54" name="TextBox 53"/>
+          <p:cNvSpPr txBox="1"/>
+          <p:nvPr/>
+        </p:nvSpPr>
+        <p:spPr>
+          <a:xfrm>
+            <a:off x="5442204" y="3328415"/>
             <a:ext cx="274320" cy="457200"/>
           </a:xfrm>
           <a:prstGeom prst="rect">
@@ -23831,14 +24119,14 @@
       </p:sp>
       <p:sp>
         <p:nvSpPr>
-          <p:cNvPr id="47" name="Rectangle 46"/>
+          <p:cNvPr id="55" name="Rectangle 54"/>
           <p:cNvSpPr/>
           <p:nvPr/>
         </p:nvSpPr>
         <p:spPr>
           <a:xfrm>
-            <a:off x="7223760" y="3154680"/>
-            <a:ext cx="1301496" cy="822960"/>
+            <a:off x="7223760" y="3108960"/>
+            <a:ext cx="1301496" cy="914400"/>
           </a:xfrm>
           <a:prstGeom prst="rect">
             <a:avLst/>
@@ -23875,13 +24163,13 @@
       </p:sp>
       <p:sp>
         <p:nvSpPr>
-          <p:cNvPr id="48" name="Rectangle 47"/>
+          <p:cNvPr id="56" name="Rectangle 55"/>
           <p:cNvSpPr/>
           <p:nvPr/>
         </p:nvSpPr>
         <p:spPr>
           <a:xfrm>
-            <a:off x="7223760" y="3154680"/>
+            <a:off x="7223760" y="3108960"/>
             <a:ext cx="1301496" cy="64008"/>
           </a:xfrm>
           <a:prstGeom prst="rect">
@@ -23919,14 +24207,14 @@
       </p:sp>
       <p:sp>
         <p:nvSpPr>
-          <p:cNvPr id="49" name="TextBox 48"/>
-          <p:cNvSpPr txBox="1"/>
-          <p:nvPr/>
-        </p:nvSpPr>
-        <p:spPr>
-          <a:xfrm>
-            <a:off x="7260336" y="3246120"/>
-            <a:ext cx="1228344" cy="475488"/>
+          <p:cNvPr id="57" name="TextBox 56"/>
+          <p:cNvSpPr txBox="1"/>
+          <p:nvPr/>
+        </p:nvSpPr>
+        <p:spPr>
+          <a:xfrm>
+            <a:off x="7260336" y="3182112"/>
+            <a:ext cx="1228344" cy="384048"/>
           </a:xfrm>
           <a:prstGeom prst="rect">
             <a:avLst/>
@@ -23954,14 +24242,50 @@
       </p:sp>
       <p:sp>
         <p:nvSpPr>
-          <p:cNvPr id="50" name="TextBox 49"/>
-          <p:cNvSpPr txBox="1"/>
-          <p:nvPr/>
-        </p:nvSpPr>
-        <p:spPr>
-          <a:xfrm>
-            <a:off x="7260336" y="3730752"/>
-            <a:ext cx="1228344" cy="219456"/>
+          <p:cNvPr id="58" name="TextBox 57"/>
+          <p:cNvSpPr txBox="1"/>
+          <p:nvPr/>
+        </p:nvSpPr>
+        <p:spPr>
+          <a:xfrm>
+            <a:off x="7260336" y="3584448"/>
+            <a:ext cx="1228344" cy="182880"/>
+          </a:xfrm>
+          <a:prstGeom prst="rect">
+            <a:avLst/>
+          </a:prstGeom>
+          <a:noFill/>
+        </p:spPr>
+        <p:txBody>
+          <a:bodyPr wrap="square" lIns="0" rIns="0" tIns="0" bIns="0">
+            <a:spAutoFit/>
+          </a:bodyPr>
+          <a:lstStyle/>
+          <a:p>
+            <a:pPr algn="ctr"/>
+            <a:r>
+              <a:rPr sz="750" u="sng">
+                <a:solidFill>
+                  <a:srgbClr val="1155CC"/>
+                </a:solidFill>
+                <a:latin typeface="Calibri"/>
+                <a:hlinkClick r:id="rId10"/>
+              </a:rPr>
+              <a:t>2505.22954</a:t>
+            </a:r>
+          </a:p>
+        </p:txBody>
+      </p:sp>
+      <p:sp>
+        <p:nvSpPr>
+          <p:cNvPr id="59" name="TextBox 58"/>
+          <p:cNvSpPr txBox="1"/>
+          <p:nvPr/>
+        </p:nvSpPr>
+        <p:spPr>
+          <a:xfrm>
+            <a:off x="7260336" y="3785615"/>
+            <a:ext cx="1228344" cy="201168"/>
           </a:xfrm>
           <a:prstGeom prst="rect">
             <a:avLst/>
@@ -23976,7 +24300,7 @@
           <a:p>
             <a:pPr algn="ctr"/>
             <a:r>
-              <a:rPr sz="800" b="0" i="0">
+              <a:rPr sz="750" b="0" i="0">
                 <a:solidFill>
                   <a:srgbClr val="5A616B"/>
                 </a:solidFill>
@@ -23989,13 +24313,13 @@
       </p:sp>
       <p:sp>
         <p:nvSpPr>
-          <p:cNvPr id="51" name="TextBox 50"/>
-          <p:cNvSpPr txBox="1"/>
-          <p:nvPr/>
-        </p:nvSpPr>
-        <p:spPr>
-          <a:xfrm>
-            <a:off x="6981444" y="3300984"/>
+          <p:cNvPr id="60" name="TextBox 59"/>
+          <p:cNvSpPr txBox="1"/>
+          <p:nvPr/>
+        </p:nvSpPr>
+        <p:spPr>
+          <a:xfrm>
+            <a:off x="6981444" y="3328415"/>
             <a:ext cx="274320" cy="457200"/>
           </a:xfrm>
           <a:prstGeom prst="rect">
@@ -24024,14 +24348,14 @@
       </p:sp>
       <p:sp>
         <p:nvSpPr>
-          <p:cNvPr id="52" name="Rectangle 51"/>
+          <p:cNvPr id="61" name="Rectangle 60"/>
           <p:cNvSpPr/>
           <p:nvPr/>
         </p:nvSpPr>
         <p:spPr>
           <a:xfrm>
-            <a:off x="8763000" y="3154680"/>
-            <a:ext cx="1301496" cy="822960"/>
+            <a:off x="8763000" y="3108960"/>
+            <a:ext cx="1301496" cy="914400"/>
           </a:xfrm>
           <a:prstGeom prst="rect">
             <a:avLst/>
@@ -24068,13 +24392,13 @@
       </p:sp>
       <p:sp>
         <p:nvSpPr>
-          <p:cNvPr id="53" name="Rectangle 52"/>
+          <p:cNvPr id="62" name="Rectangle 61"/>
           <p:cNvSpPr/>
           <p:nvPr/>
         </p:nvSpPr>
         <p:spPr>
           <a:xfrm>
-            <a:off x="8763000" y="3154680"/>
+            <a:off x="8763000" y="3108960"/>
             <a:ext cx="1301496" cy="64008"/>
           </a:xfrm>
           <a:prstGeom prst="rect">
@@ -24112,14 +24436,14 @@
       </p:sp>
       <p:sp>
         <p:nvSpPr>
-          <p:cNvPr id="54" name="TextBox 53"/>
-          <p:cNvSpPr txBox="1"/>
-          <p:nvPr/>
-        </p:nvSpPr>
-        <p:spPr>
-          <a:xfrm>
-            <a:off x="8799576" y="3246120"/>
-            <a:ext cx="1228344" cy="475488"/>
+          <p:cNvPr id="63" name="TextBox 62"/>
+          <p:cNvSpPr txBox="1"/>
+          <p:nvPr/>
+        </p:nvSpPr>
+        <p:spPr>
+          <a:xfrm>
+            <a:off x="8799576" y="3182112"/>
+            <a:ext cx="1228344" cy="384048"/>
           </a:xfrm>
           <a:prstGeom prst="rect">
             <a:avLst/>
@@ -24147,14 +24471,50 @@
       </p:sp>
       <p:sp>
         <p:nvSpPr>
-          <p:cNvPr id="55" name="TextBox 54"/>
-          <p:cNvSpPr txBox="1"/>
-          <p:nvPr/>
-        </p:nvSpPr>
-        <p:spPr>
-          <a:xfrm>
-            <a:off x="8799576" y="3730752"/>
-            <a:ext cx="1228344" cy="219456"/>
+          <p:cNvPr id="64" name="TextBox 63"/>
+          <p:cNvSpPr txBox="1"/>
+          <p:nvPr/>
+        </p:nvSpPr>
+        <p:spPr>
+          <a:xfrm>
+            <a:off x="8799576" y="3584448"/>
+            <a:ext cx="1228344" cy="182880"/>
+          </a:xfrm>
+          <a:prstGeom prst="rect">
+            <a:avLst/>
+          </a:prstGeom>
+          <a:noFill/>
+        </p:spPr>
+        <p:txBody>
+          <a:bodyPr wrap="square" lIns="0" rIns="0" tIns="0" bIns="0">
+            <a:spAutoFit/>
+          </a:bodyPr>
+          <a:lstStyle/>
+          <a:p>
+            <a:pPr algn="ctr"/>
+            <a:r>
+              <a:rPr sz="750" u="sng">
+                <a:solidFill>
+                  <a:srgbClr val="1155CC"/>
+                </a:solidFill>
+                <a:latin typeface="Calibri"/>
+                <a:hlinkClick r:id="rId11"/>
+              </a:rPr>
+              <a:t>2607.05904</a:t>
+            </a:r>
+          </a:p>
+        </p:txBody>
+      </p:sp>
+      <p:sp>
+        <p:nvSpPr>
+          <p:cNvPr id="65" name="TextBox 64"/>
+          <p:cNvSpPr txBox="1"/>
+          <p:nvPr/>
+        </p:nvSpPr>
+        <p:spPr>
+          <a:xfrm>
+            <a:off x="8799576" y="3785615"/>
+            <a:ext cx="1228344" cy="201168"/>
           </a:xfrm>
           <a:prstGeom prst="rect">
             <a:avLst/>
@@ -24169,7 +24529,7 @@
           <a:p>
             <a:pPr algn="ctr"/>
             <a:r>
-              <a:rPr sz="800" b="0" i="0">
+              <a:rPr sz="750" b="0" i="0">
                 <a:solidFill>
                   <a:srgbClr val="5A616B"/>
                 </a:solidFill>
@@ -24182,13 +24542,13 @@
       </p:sp>
       <p:sp>
         <p:nvSpPr>
-          <p:cNvPr id="56" name="TextBox 55"/>
-          <p:cNvSpPr txBox="1"/>
-          <p:nvPr/>
-        </p:nvSpPr>
-        <p:spPr>
-          <a:xfrm>
-            <a:off x="8520684" y="3300984"/>
+          <p:cNvPr id="66" name="TextBox 65"/>
+          <p:cNvSpPr txBox="1"/>
+          <p:nvPr/>
+        </p:nvSpPr>
+        <p:spPr>
+          <a:xfrm>
+            <a:off x="8520684" y="3328415"/>
             <a:ext cx="274320" cy="457200"/>
           </a:xfrm>
           <a:prstGeom prst="rect">
@@ -24217,14 +24577,14 @@
       </p:sp>
       <p:sp>
         <p:nvSpPr>
-          <p:cNvPr id="57" name="Rectangle 56"/>
+          <p:cNvPr id="67" name="Rectangle 66"/>
           <p:cNvSpPr/>
           <p:nvPr/>
         </p:nvSpPr>
         <p:spPr>
           <a:xfrm>
-            <a:off x="10302240" y="3154680"/>
-            <a:ext cx="1301496" cy="822960"/>
+            <a:off x="10302240" y="3108960"/>
+            <a:ext cx="1301496" cy="914400"/>
           </a:xfrm>
           <a:prstGeom prst="rect">
             <a:avLst/>
@@ -24261,14 +24621,14 @@
       </p:sp>
       <p:sp>
         <p:nvSpPr>
-          <p:cNvPr id="58" name="TextBox 57"/>
-          <p:cNvSpPr txBox="1"/>
-          <p:nvPr/>
-        </p:nvSpPr>
-        <p:spPr>
-          <a:xfrm>
-            <a:off x="10338815" y="3246120"/>
-            <a:ext cx="1228344" cy="475488"/>
+          <p:cNvPr id="68" name="TextBox 67"/>
+          <p:cNvSpPr txBox="1"/>
+          <p:nvPr/>
+        </p:nvSpPr>
+        <p:spPr>
+          <a:xfrm>
+            <a:off x="10338815" y="3182112"/>
+            <a:ext cx="1228344" cy="384048"/>
           </a:xfrm>
           <a:prstGeom prst="rect">
             <a:avLst/>
@@ -24296,14 +24656,50 @@
       </p:sp>
       <p:sp>
         <p:nvSpPr>
-          <p:cNvPr id="59" name="TextBox 58"/>
-          <p:cNvSpPr txBox="1"/>
-          <p:nvPr/>
-        </p:nvSpPr>
-        <p:spPr>
-          <a:xfrm>
-            <a:off x="10338815" y="3730752"/>
-            <a:ext cx="1228344" cy="219456"/>
+          <p:cNvPr id="69" name="TextBox 68"/>
+          <p:cNvSpPr txBox="1"/>
+          <p:nvPr/>
+        </p:nvSpPr>
+        <p:spPr>
+          <a:xfrm>
+            <a:off x="10338815" y="3584448"/>
+            <a:ext cx="1228344" cy="182880"/>
+          </a:xfrm>
+          <a:prstGeom prst="rect">
+            <a:avLst/>
+          </a:prstGeom>
+          <a:noFill/>
+        </p:spPr>
+        <p:txBody>
+          <a:bodyPr wrap="square" lIns="0" rIns="0" tIns="0" bIns="0">
+            <a:spAutoFit/>
+          </a:bodyPr>
+          <a:lstStyle/>
+          <a:p>
+            <a:pPr algn="ctr"/>
+            <a:r>
+              <a:rPr sz="750" u="sng">
+                <a:solidFill>
+                  <a:srgbClr val="FFFFFF"/>
+                </a:solidFill>
+                <a:latin typeface="Calibri"/>
+                <a:hlinkClick r:id="rId6"/>
+              </a:rPr>
+              <a:t>repo ↗</a:t>
+            </a:r>
+          </a:p>
+        </p:txBody>
+      </p:sp>
+      <p:sp>
+        <p:nvSpPr>
+          <p:cNvPr id="70" name="TextBox 69"/>
+          <p:cNvSpPr txBox="1"/>
+          <p:nvPr/>
+        </p:nvSpPr>
+        <p:spPr>
+          <a:xfrm>
+            <a:off x="10338815" y="3785615"/>
+            <a:ext cx="1228344" cy="201168"/>
           </a:xfrm>
           <a:prstGeom prst="rect">
             <a:avLst/>
@@ -24318,7 +24714,7 @@
           <a:p>
             <a:pPr algn="ctr"/>
             <a:r>
-              <a:rPr sz="800" b="0" i="0">
+              <a:rPr sz="750" b="0" i="0">
                 <a:solidFill>
                   <a:srgbClr val="FFFFFF"/>
                 </a:solidFill>
@@ -24331,13 +24727,13 @@
       </p:sp>
       <p:sp>
         <p:nvSpPr>
-          <p:cNvPr id="60" name="TextBox 59"/>
-          <p:cNvSpPr txBox="1"/>
-          <p:nvPr/>
-        </p:nvSpPr>
-        <p:spPr>
-          <a:xfrm>
-            <a:off x="10059923" y="3300984"/>
+          <p:cNvPr id="71" name="TextBox 70"/>
+          <p:cNvSpPr txBox="1"/>
+          <p:nvPr/>
+        </p:nvSpPr>
+        <p:spPr>
+          <a:xfrm>
+            <a:off x="10059923" y="3328415"/>
             <a:ext cx="274320" cy="457200"/>
           </a:xfrm>
           <a:prstGeom prst="rect">
@@ -24366,14 +24762,14 @@
       </p:sp>
       <p:sp>
         <p:nvSpPr>
-          <p:cNvPr id="61" name="Rectangle 60"/>
+          <p:cNvPr id="72" name="Rectangle 71"/>
           <p:cNvSpPr/>
           <p:nvPr/>
         </p:nvSpPr>
         <p:spPr>
           <a:xfrm>
-            <a:off x="548640" y="4572000"/>
-            <a:ext cx="1874519" cy="822960"/>
+            <a:off x="548640" y="4526280"/>
+            <a:ext cx="1874519" cy="914400"/>
           </a:xfrm>
           <a:prstGeom prst="rect">
             <a:avLst/>
@@ -24410,14 +24806,14 @@
       </p:sp>
       <p:sp>
         <p:nvSpPr>
-          <p:cNvPr id="62" name="TextBox 61"/>
-          <p:cNvSpPr txBox="1"/>
-          <p:nvPr/>
-        </p:nvSpPr>
-        <p:spPr>
-          <a:xfrm>
-            <a:off x="548640" y="4572000"/>
-            <a:ext cx="1874519" cy="822960"/>
+          <p:cNvPr id="73" name="TextBox 72"/>
+          <p:cNvSpPr txBox="1"/>
+          <p:nvPr/>
+        </p:nvSpPr>
+        <p:spPr>
+          <a:xfrm>
+            <a:off x="548640" y="4526280"/>
+            <a:ext cx="1874519" cy="914400"/>
           </a:xfrm>
           <a:prstGeom prst="rect">
             <a:avLst/>
@@ -24445,14 +24841,14 @@
       </p:sp>
       <p:sp>
         <p:nvSpPr>
-          <p:cNvPr id="63" name="Rectangle 62"/>
+          <p:cNvPr id="74" name="Rectangle 73"/>
           <p:cNvSpPr/>
           <p:nvPr/>
         </p:nvSpPr>
         <p:spPr>
           <a:xfrm>
-            <a:off x="2606040" y="4572000"/>
-            <a:ext cx="2071115" cy="822960"/>
+            <a:off x="2606040" y="4526280"/>
+            <a:ext cx="2071115" cy="914400"/>
           </a:xfrm>
           <a:prstGeom prst="rect">
             <a:avLst/>
@@ -24489,13 +24885,13 @@
       </p:sp>
       <p:sp>
         <p:nvSpPr>
-          <p:cNvPr id="64" name="Rectangle 63"/>
+          <p:cNvPr id="75" name="Rectangle 74"/>
           <p:cNvSpPr/>
           <p:nvPr/>
         </p:nvSpPr>
         <p:spPr>
           <a:xfrm>
-            <a:off x="2606040" y="4572000"/>
+            <a:off x="2606040" y="4526280"/>
             <a:ext cx="2071115" cy="64008"/>
           </a:xfrm>
           <a:prstGeom prst="rect">
@@ -24533,14 +24929,14 @@
       </p:sp>
       <p:sp>
         <p:nvSpPr>
-          <p:cNvPr id="65" name="TextBox 64"/>
-          <p:cNvSpPr txBox="1"/>
-          <p:nvPr/>
-        </p:nvSpPr>
-        <p:spPr>
-          <a:xfrm>
-            <a:off x="2642616" y="4663440"/>
-            <a:ext cx="1997963" cy="475488"/>
+          <p:cNvPr id="76" name="TextBox 75"/>
+          <p:cNvSpPr txBox="1"/>
+          <p:nvPr/>
+        </p:nvSpPr>
+        <p:spPr>
+          <a:xfrm>
+            <a:off x="2642616" y="4599432"/>
+            <a:ext cx="1997963" cy="384048"/>
           </a:xfrm>
           <a:prstGeom prst="rect">
             <a:avLst/>
@@ -24568,14 +24964,50 @@
       </p:sp>
       <p:sp>
         <p:nvSpPr>
-          <p:cNvPr id="66" name="TextBox 65"/>
-          <p:cNvSpPr txBox="1"/>
-          <p:nvPr/>
-        </p:nvSpPr>
-        <p:spPr>
-          <a:xfrm>
-            <a:off x="2642616" y="5148072"/>
-            <a:ext cx="1997963" cy="219456"/>
+          <p:cNvPr id="77" name="TextBox 76"/>
+          <p:cNvSpPr txBox="1"/>
+          <p:nvPr/>
+        </p:nvSpPr>
+        <p:spPr>
+          <a:xfrm>
+            <a:off x="2642616" y="5001768"/>
+            <a:ext cx="1997963" cy="182880"/>
+          </a:xfrm>
+          <a:prstGeom prst="rect">
+            <a:avLst/>
+          </a:prstGeom>
+          <a:noFill/>
+        </p:spPr>
+        <p:txBody>
+          <a:bodyPr wrap="square" lIns="0" rIns="0" tIns="0" bIns="0">
+            <a:spAutoFit/>
+          </a:bodyPr>
+          <a:lstStyle/>
+          <a:p>
+            <a:pPr algn="ctr"/>
+            <a:r>
+              <a:rPr sz="750" u="sng">
+                <a:solidFill>
+                  <a:srgbClr val="1155CC"/>
+                </a:solidFill>
+                <a:latin typeface="Calibri"/>
+                <a:hlinkClick r:id="rId12"/>
+              </a:rPr>
+              <a:t>2505.02709</a:t>
+            </a:r>
+          </a:p>
+        </p:txBody>
+      </p:sp>
+      <p:sp>
+        <p:nvSpPr>
+          <p:cNvPr id="78" name="TextBox 77"/>
+          <p:cNvSpPr txBox="1"/>
+          <p:nvPr/>
+        </p:nvSpPr>
+        <p:spPr>
+          <a:xfrm>
+            <a:off x="2642616" y="5202936"/>
+            <a:ext cx="1997963" cy="201168"/>
           </a:xfrm>
           <a:prstGeom prst="rect">
             <a:avLst/>
@@ -24590,7 +25022,7 @@
           <a:p>
             <a:pPr algn="ctr"/>
             <a:r>
-              <a:rPr sz="800" b="0" i="0">
+              <a:rPr sz="750" b="0" i="0">
                 <a:solidFill>
                   <a:srgbClr val="5A616B"/>
                 </a:solidFill>
@@ -24603,14 +25035,14 @@
       </p:sp>
       <p:sp>
         <p:nvSpPr>
-          <p:cNvPr id="67" name="Rectangle 66"/>
+          <p:cNvPr id="79" name="Rectangle 78"/>
           <p:cNvSpPr/>
           <p:nvPr/>
         </p:nvSpPr>
         <p:spPr>
           <a:xfrm>
-            <a:off x="4914900" y="4572000"/>
-            <a:ext cx="2071115" cy="822960"/>
+            <a:off x="4914900" y="4526280"/>
+            <a:ext cx="2071115" cy="914400"/>
           </a:xfrm>
           <a:prstGeom prst="rect">
             <a:avLst/>
@@ -24647,13 +25079,13 @@
       </p:sp>
       <p:sp>
         <p:nvSpPr>
-          <p:cNvPr id="68" name="Rectangle 67"/>
+          <p:cNvPr id="80" name="Rectangle 79"/>
           <p:cNvSpPr/>
           <p:nvPr/>
         </p:nvSpPr>
         <p:spPr>
           <a:xfrm>
-            <a:off x="4914900" y="4572000"/>
+            <a:off x="4914900" y="4526280"/>
             <a:ext cx="2071115" cy="64008"/>
           </a:xfrm>
           <a:prstGeom prst="rect">
@@ -24691,14 +25123,14 @@
       </p:sp>
       <p:sp>
         <p:nvSpPr>
-          <p:cNvPr id="69" name="TextBox 68"/>
-          <p:cNvSpPr txBox="1"/>
-          <p:nvPr/>
-        </p:nvSpPr>
-        <p:spPr>
-          <a:xfrm>
-            <a:off x="4951476" y="4663440"/>
-            <a:ext cx="1997963" cy="475488"/>
+          <p:cNvPr id="81" name="TextBox 80"/>
+          <p:cNvSpPr txBox="1"/>
+          <p:nvPr/>
+        </p:nvSpPr>
+        <p:spPr>
+          <a:xfrm>
+            <a:off x="4951476" y="4599432"/>
+            <a:ext cx="1997963" cy="384048"/>
           </a:xfrm>
           <a:prstGeom prst="rect">
             <a:avLst/>
@@ -24726,14 +25158,50 @@
       </p:sp>
       <p:sp>
         <p:nvSpPr>
-          <p:cNvPr id="70" name="TextBox 69"/>
-          <p:cNvSpPr txBox="1"/>
-          <p:nvPr/>
-        </p:nvSpPr>
-        <p:spPr>
-          <a:xfrm>
-            <a:off x="4951476" y="5148072"/>
-            <a:ext cx="1997963" cy="219456"/>
+          <p:cNvPr id="82" name="TextBox 81"/>
+          <p:cNvSpPr txBox="1"/>
+          <p:nvPr/>
+        </p:nvSpPr>
+        <p:spPr>
+          <a:xfrm>
+            <a:off x="4951476" y="5001768"/>
+            <a:ext cx="1997963" cy="182880"/>
+          </a:xfrm>
+          <a:prstGeom prst="rect">
+            <a:avLst/>
+          </a:prstGeom>
+          <a:noFill/>
+        </p:spPr>
+        <p:txBody>
+          <a:bodyPr wrap="square" lIns="0" rIns="0" tIns="0" bIns="0">
+            <a:spAutoFit/>
+          </a:bodyPr>
+          <a:lstStyle/>
+          <a:p>
+            <a:pPr algn="ctr"/>
+            <a:r>
+              <a:rPr sz="750" u="sng">
+                <a:solidFill>
+                  <a:srgbClr val="1155CC"/>
+                </a:solidFill>
+                <a:latin typeface="Calibri"/>
+                <a:hlinkClick r:id="rId13"/>
+              </a:rPr>
+              <a:t>2603.03456</a:t>
+            </a:r>
+          </a:p>
+        </p:txBody>
+      </p:sp>
+      <p:sp>
+        <p:nvSpPr>
+          <p:cNvPr id="83" name="TextBox 82"/>
+          <p:cNvSpPr txBox="1"/>
+          <p:nvPr/>
+        </p:nvSpPr>
+        <p:spPr>
+          <a:xfrm>
+            <a:off x="4951476" y="5202936"/>
+            <a:ext cx="1997963" cy="201168"/>
           </a:xfrm>
           <a:prstGeom prst="rect">
             <a:avLst/>
@@ -24748,7 +25216,7 @@
           <a:p>
             <a:pPr algn="ctr"/>
             <a:r>
-              <a:rPr sz="800" b="0" i="0">
+              <a:rPr sz="750" b="0" i="0">
                 <a:solidFill>
                   <a:srgbClr val="5A616B"/>
                 </a:solidFill>
@@ -24761,13 +25229,13 @@
       </p:sp>
       <p:sp>
         <p:nvSpPr>
-          <p:cNvPr id="71" name="TextBox 70"/>
-          <p:cNvSpPr txBox="1"/>
-          <p:nvPr/>
-        </p:nvSpPr>
-        <p:spPr>
-          <a:xfrm>
-            <a:off x="4672584" y="4718304"/>
+          <p:cNvPr id="84" name="TextBox 83"/>
+          <p:cNvSpPr txBox="1"/>
+          <p:nvPr/>
+        </p:nvSpPr>
+        <p:spPr>
+          <a:xfrm>
+            <a:off x="4672584" y="4745736"/>
             <a:ext cx="274320" cy="457200"/>
           </a:xfrm>
           <a:prstGeom prst="rect">
@@ -24796,14 +25264,14 @@
       </p:sp>
       <p:sp>
         <p:nvSpPr>
-          <p:cNvPr id="72" name="Rectangle 71"/>
+          <p:cNvPr id="85" name="Rectangle 84"/>
           <p:cNvSpPr/>
           <p:nvPr/>
         </p:nvSpPr>
         <p:spPr>
           <a:xfrm>
-            <a:off x="7223760" y="4572000"/>
-            <a:ext cx="2071115" cy="822960"/>
+            <a:off x="7223760" y="4526280"/>
+            <a:ext cx="2071115" cy="914400"/>
           </a:xfrm>
           <a:prstGeom prst="rect">
             <a:avLst/>
@@ -24840,13 +25308,13 @@
       </p:sp>
       <p:sp>
         <p:nvSpPr>
-          <p:cNvPr id="73" name="Rectangle 72"/>
+          <p:cNvPr id="86" name="Rectangle 85"/>
           <p:cNvSpPr/>
           <p:nvPr/>
         </p:nvSpPr>
         <p:spPr>
           <a:xfrm>
-            <a:off x="7223760" y="4572000"/>
+            <a:off x="7223760" y="4526280"/>
             <a:ext cx="2071115" cy="64008"/>
           </a:xfrm>
           <a:prstGeom prst="rect">
@@ -24884,14 +25352,14 @@
       </p:sp>
       <p:sp>
         <p:nvSpPr>
-          <p:cNvPr id="74" name="TextBox 73"/>
-          <p:cNvSpPr txBox="1"/>
-          <p:nvPr/>
-        </p:nvSpPr>
-        <p:spPr>
-          <a:xfrm>
-            <a:off x="7260336" y="4663440"/>
-            <a:ext cx="1997963" cy="475488"/>
+          <p:cNvPr id="87" name="TextBox 86"/>
+          <p:cNvSpPr txBox="1"/>
+          <p:nvPr/>
+        </p:nvSpPr>
+        <p:spPr>
+          <a:xfrm>
+            <a:off x="7260336" y="4599432"/>
+            <a:ext cx="1997963" cy="384048"/>
           </a:xfrm>
           <a:prstGeom prst="rect">
             <a:avLst/>
@@ -24919,14 +25387,50 @@
       </p:sp>
       <p:sp>
         <p:nvSpPr>
-          <p:cNvPr id="75" name="TextBox 74"/>
-          <p:cNvSpPr txBox="1"/>
-          <p:nvPr/>
-        </p:nvSpPr>
-        <p:spPr>
-          <a:xfrm>
-            <a:off x="7260336" y="5148072"/>
-            <a:ext cx="1997963" cy="219456"/>
+          <p:cNvPr id="88" name="TextBox 87"/>
+          <p:cNvSpPr txBox="1"/>
+          <p:nvPr/>
+        </p:nvSpPr>
+        <p:spPr>
+          <a:xfrm>
+            <a:off x="7260336" y="5001768"/>
+            <a:ext cx="1997963" cy="182880"/>
+          </a:xfrm>
+          <a:prstGeom prst="rect">
+            <a:avLst/>
+          </a:prstGeom>
+          <a:noFill/>
+        </p:spPr>
+        <p:txBody>
+          <a:bodyPr wrap="square" lIns="0" rIns="0" tIns="0" bIns="0">
+            <a:spAutoFit/>
+          </a:bodyPr>
+          <a:lstStyle/>
+          <a:p>
+            <a:pPr algn="ctr"/>
+            <a:r>
+              <a:rPr sz="750" u="sng">
+                <a:solidFill>
+                  <a:srgbClr val="1155CC"/>
+                </a:solidFill>
+                <a:latin typeface="Calibri"/>
+                <a:hlinkClick r:id="rId14"/>
+              </a:rPr>
+              <a:t>2609.05975</a:t>
+            </a:r>
+          </a:p>
+        </p:txBody>
+      </p:sp>
+      <p:sp>
+        <p:nvSpPr>
+          <p:cNvPr id="89" name="TextBox 88"/>
+          <p:cNvSpPr txBox="1"/>
+          <p:nvPr/>
+        </p:nvSpPr>
+        <p:spPr>
+          <a:xfrm>
+            <a:off x="7260336" y="5202936"/>
+            <a:ext cx="1997963" cy="201168"/>
           </a:xfrm>
           <a:prstGeom prst="rect">
             <a:avLst/>
@@ -24941,7 +25445,7 @@
           <a:p>
             <a:pPr algn="ctr"/>
             <a:r>
-              <a:rPr sz="800" b="0" i="0">
+              <a:rPr sz="750" b="0" i="0">
                 <a:solidFill>
                   <a:srgbClr val="5A616B"/>
                 </a:solidFill>
@@ -24954,13 +25458,13 @@
       </p:sp>
       <p:sp>
         <p:nvSpPr>
-          <p:cNvPr id="76" name="TextBox 75"/>
-          <p:cNvSpPr txBox="1"/>
-          <p:nvPr/>
-        </p:nvSpPr>
-        <p:spPr>
-          <a:xfrm>
-            <a:off x="6981444" y="4718304"/>
+          <p:cNvPr id="90" name="TextBox 89"/>
+          <p:cNvSpPr txBox="1"/>
+          <p:nvPr/>
+        </p:nvSpPr>
+        <p:spPr>
+          <a:xfrm>
+            <a:off x="6981444" y="4745736"/>
             <a:ext cx="274320" cy="457200"/>
           </a:xfrm>
           <a:prstGeom prst="rect">
@@ -24989,14 +25493,14 @@
       </p:sp>
       <p:sp>
         <p:nvSpPr>
-          <p:cNvPr id="77" name="Rectangle 76"/>
+          <p:cNvPr id="91" name="Rectangle 90"/>
           <p:cNvSpPr/>
           <p:nvPr/>
         </p:nvSpPr>
         <p:spPr>
           <a:xfrm>
-            <a:off x="9532619" y="4572000"/>
-            <a:ext cx="2071115" cy="822960"/>
+            <a:off x="9532619" y="4526280"/>
+            <a:ext cx="2071115" cy="914400"/>
           </a:xfrm>
           <a:prstGeom prst="rect">
             <a:avLst/>
@@ -25033,14 +25537,14 @@
       </p:sp>
       <p:sp>
         <p:nvSpPr>
-          <p:cNvPr id="78" name="TextBox 77"/>
-          <p:cNvSpPr txBox="1"/>
-          <p:nvPr/>
-        </p:nvSpPr>
-        <p:spPr>
-          <a:xfrm>
-            <a:off x="9569195" y="4663440"/>
-            <a:ext cx="1997963" cy="475488"/>
+          <p:cNvPr id="92" name="TextBox 91"/>
+          <p:cNvSpPr txBox="1"/>
+          <p:nvPr/>
+        </p:nvSpPr>
+        <p:spPr>
+          <a:xfrm>
+            <a:off x="9569195" y="4599432"/>
+            <a:ext cx="1997963" cy="384048"/>
           </a:xfrm>
           <a:prstGeom prst="rect">
             <a:avLst/>
@@ -25068,14 +25572,50 @@
       </p:sp>
       <p:sp>
         <p:nvSpPr>
-          <p:cNvPr id="79" name="TextBox 78"/>
-          <p:cNvSpPr txBox="1"/>
-          <p:nvPr/>
-        </p:nvSpPr>
-        <p:spPr>
-          <a:xfrm>
-            <a:off x="9569195" y="5148072"/>
-            <a:ext cx="1997963" cy="219456"/>
+          <p:cNvPr id="93" name="TextBox 92"/>
+          <p:cNvSpPr txBox="1"/>
+          <p:nvPr/>
+        </p:nvSpPr>
+        <p:spPr>
+          <a:xfrm>
+            <a:off x="9569195" y="5001768"/>
+            <a:ext cx="1997963" cy="182880"/>
+          </a:xfrm>
+          <a:prstGeom prst="rect">
+            <a:avLst/>
+          </a:prstGeom>
+          <a:noFill/>
+        </p:spPr>
+        <p:txBody>
+          <a:bodyPr wrap="square" lIns="0" rIns="0" tIns="0" bIns="0">
+            <a:spAutoFit/>
+          </a:bodyPr>
+          <a:lstStyle/>
+          <a:p>
+            <a:pPr algn="ctr"/>
+            <a:r>
+              <a:rPr sz="750" u="sng">
+                <a:solidFill>
+                  <a:srgbClr val="FFFFFF"/>
+                </a:solidFill>
+                <a:latin typeface="Calibri"/>
+                <a:hlinkClick r:id="rId6"/>
+              </a:rPr>
+              <a:t>repo ↗</a:t>
+            </a:r>
+          </a:p>
+        </p:txBody>
+      </p:sp>
+      <p:sp>
+        <p:nvSpPr>
+          <p:cNvPr id="94" name="TextBox 93"/>
+          <p:cNvSpPr txBox="1"/>
+          <p:nvPr/>
+        </p:nvSpPr>
+        <p:spPr>
+          <a:xfrm>
+            <a:off x="9569195" y="5202936"/>
+            <a:ext cx="1997963" cy="201168"/>
           </a:xfrm>
           <a:prstGeom prst="rect">
             <a:avLst/>
@@ -25090,7 +25630,7 @@
           <a:p>
             <a:pPr algn="ctr"/>
             <a:r>
-              <a:rPr sz="800" b="0" i="0">
+              <a:rPr sz="750" b="0" i="0">
                 <a:solidFill>
                   <a:srgbClr val="FFFFFF"/>
                 </a:solidFill>
@@ -25103,13 +25643,13 @@
       </p:sp>
       <p:sp>
         <p:nvSpPr>
-          <p:cNvPr id="80" name="TextBox 79"/>
-          <p:cNvSpPr txBox="1"/>
-          <p:nvPr/>
-        </p:nvSpPr>
-        <p:spPr>
-          <a:xfrm>
-            <a:off x="9290303" y="4718304"/>
+          <p:cNvPr id="95" name="TextBox 94"/>
+          <p:cNvSpPr txBox="1"/>
+          <p:nvPr/>
+        </p:nvSpPr>
+        <p:spPr>
+          <a:xfrm>
+            <a:off x="9290303" y="4745736"/>
             <a:ext cx="274320" cy="457200"/>
           </a:xfrm>
           <a:prstGeom prst="rect">
@@ -25138,7 +25678,7 @@
       </p:sp>
       <p:sp>
         <p:nvSpPr>
-          <p:cNvPr id="81" name="TextBox 80"/>
+          <p:cNvPr id="96" name="TextBox 95"/>
           <p:cNvSpPr txBox="1"/>
           <p:nvPr/>
         </p:nvSpPr>
@@ -25173,7 +25713,7 @@
       </p:sp>
       <p:sp>
         <p:nvSpPr>
-          <p:cNvPr id="82" name="TextBox 81"/>
+          <p:cNvPr id="97" name="TextBox 96"/>
           <p:cNvSpPr txBox="1"/>
           <p:nvPr/>
         </p:nvSpPr>

</xml_diff>